<commit_message>
changed planar robot image
</commit_message>
<xml_diff>
--- a/robotics/Resources/Images/Modelling/Robot images.pptx
+++ b/robotics/Resources/Images/Modelling/Robot images.pptx
@@ -3697,8 +3697,8 @@
             </a:p>
           </p:txBody>
         </p:sp>
-        <mc:AlternateContent xmlns:mc="http://schemas.openxmlformats.org/markup-compatibility/2006">
-          <mc:Choice xmlns:a14="http://schemas.microsoft.com/office/drawing/2010/main" Requires="a14">
+        <mc:AlternateContent xmlns:mc="http://schemas.openxmlformats.org/markup-compatibility/2006" xmlns:a14="http://schemas.microsoft.com/office/drawing/2010/main">
+          <mc:Choice Requires="a14">
             <p:sp>
               <p:nvSpPr>
                 <p:cNvPr id="43" name="Textfeld 42">
@@ -3727,6 +3727,7 @@
                 </a:bodyPr>
                 <a:lstStyle/>
                 <a:p>
+                  <a:pPr/>
                   <a14:m>
                     <m:oMathPara xmlns:m="http://schemas.openxmlformats.org/officeDocument/2006/math">
                       <m:oMathParaPr>
@@ -3736,7 +3737,7 @@
                         <m:sSub>
                           <m:sSubPr>
                             <m:ctrlPr>
-                              <a:rPr lang="de-DE" dirty="0">
+                              <a:rPr lang="de-DE" i="1" dirty="0">
                                 <a:latin typeface="Cambria Math" panose="02040503050406030204" pitchFamily="18" charset="0"/>
                               </a:rPr>
                             </m:ctrlPr>
@@ -3772,7 +3773,7 @@
               </p:txBody>
             </p:sp>
           </mc:Choice>
-          <mc:Fallback>
+          <mc:Fallback xmlns="">
             <p:sp>
               <p:nvSpPr>
                 <p:cNvPr id="43" name="Textfeld 42">
@@ -3962,8 +3963,8 @@
             </a:fontRef>
           </p:style>
         </p:cxnSp>
-        <mc:AlternateContent xmlns:mc="http://schemas.openxmlformats.org/markup-compatibility/2006">
-          <mc:Choice xmlns:a14="http://schemas.microsoft.com/office/drawing/2010/main" Requires="a14">
+        <mc:AlternateContent xmlns:mc="http://schemas.openxmlformats.org/markup-compatibility/2006" xmlns:a14="http://schemas.microsoft.com/office/drawing/2010/main">
+          <mc:Choice Requires="a14">
             <p:sp>
               <p:nvSpPr>
                 <p:cNvPr id="24" name="Textfeld 23">
@@ -3992,6 +3993,7 @@
                 </a:bodyPr>
                 <a:lstStyle/>
                 <a:p>
+                  <a:pPr/>
                   <a14:m>
                     <m:oMathPara xmlns:m="http://schemas.openxmlformats.org/officeDocument/2006/math">
                       <m:oMathParaPr>
@@ -4001,7 +4003,7 @@
                         <m:sSub>
                           <m:sSubPr>
                             <m:ctrlPr>
-                              <a:rPr lang="de-DE" b="0" i="0" dirty="0" smtClean="0">
+                              <a:rPr lang="de-DE" b="0" i="1" dirty="0" smtClean="0">
                                 <a:latin typeface="Cambria Math" panose="02040503050406030204" pitchFamily="18" charset="0"/>
                               </a:rPr>
                             </m:ctrlPr>
@@ -4034,7 +4036,7 @@
               </p:txBody>
             </p:sp>
           </mc:Choice>
-          <mc:Fallback>
+          <mc:Fallback xmlns="">
             <p:sp>
               <p:nvSpPr>
                 <p:cNvPr id="24" name="Textfeld 23">
@@ -4079,8 +4081,8 @@
             </p:sp>
           </mc:Fallback>
         </mc:AlternateContent>
-        <mc:AlternateContent xmlns:mc="http://schemas.openxmlformats.org/markup-compatibility/2006">
-          <mc:Choice xmlns:a14="http://schemas.microsoft.com/office/drawing/2010/main" Requires="a14">
+        <mc:AlternateContent xmlns:mc="http://schemas.openxmlformats.org/markup-compatibility/2006" xmlns:a14="http://schemas.microsoft.com/office/drawing/2010/main">
+          <mc:Choice Requires="a14">
             <p:sp>
               <p:nvSpPr>
                 <p:cNvPr id="25" name="Textfeld 24">
@@ -4109,6 +4111,7 @@
                 </a:bodyPr>
                 <a:lstStyle/>
                 <a:p>
+                  <a:pPr/>
                   <a14:m>
                     <m:oMathPara xmlns:m="http://schemas.openxmlformats.org/officeDocument/2006/math">
                       <m:oMathParaPr>
@@ -4118,7 +4121,7 @@
                         <m:sSub>
                           <m:sSubPr>
                             <m:ctrlPr>
-                              <a:rPr lang="de-DE" dirty="0">
+                              <a:rPr lang="de-DE" i="1" dirty="0">
                                 <a:latin typeface="Cambria Math" panose="02040503050406030204" pitchFamily="18" charset="0"/>
                               </a:rPr>
                             </m:ctrlPr>
@@ -4151,7 +4154,7 @@
               </p:txBody>
             </p:sp>
           </mc:Choice>
-          <mc:Fallback>
+          <mc:Fallback xmlns="">
             <p:sp>
               <p:nvSpPr>
                 <p:cNvPr id="25" name="Textfeld 24">
@@ -4196,8 +4199,8 @@
             </p:sp>
           </mc:Fallback>
         </mc:AlternateContent>
-        <mc:AlternateContent xmlns:mc="http://schemas.openxmlformats.org/markup-compatibility/2006">
-          <mc:Choice xmlns:a14="http://schemas.microsoft.com/office/drawing/2010/main" Requires="a14">
+        <mc:AlternateContent xmlns:mc="http://schemas.openxmlformats.org/markup-compatibility/2006" xmlns:a14="http://schemas.microsoft.com/office/drawing/2010/main">
+          <mc:Choice Requires="a14">
             <p:sp>
               <p:nvSpPr>
                 <p:cNvPr id="26" name="Textfeld 25">
@@ -4226,6 +4229,7 @@
                 </a:bodyPr>
                 <a:lstStyle/>
                 <a:p>
+                  <a:pPr/>
                   <a14:m>
                     <m:oMathPara xmlns:m="http://schemas.openxmlformats.org/officeDocument/2006/math">
                       <m:oMathParaPr>
@@ -4235,7 +4239,7 @@
                         <m:sSub>
                           <m:sSubPr>
                             <m:ctrlPr>
-                              <a:rPr lang="de-DE" b="0" i="0" dirty="0" smtClean="0">
+                              <a:rPr lang="de-DE" b="0" i="1" dirty="0" smtClean="0">
                                 <a:latin typeface="Cambria Math" panose="02040503050406030204" pitchFamily="18" charset="0"/>
                               </a:rPr>
                             </m:ctrlPr>
@@ -4268,7 +4272,7 @@
               </p:txBody>
             </p:sp>
           </mc:Choice>
-          <mc:Fallback>
+          <mc:Fallback xmlns="">
             <p:sp>
               <p:nvSpPr>
                 <p:cNvPr id="26" name="Textfeld 25">
@@ -4511,8 +4515,8 @@
             </a:fontRef>
           </p:style>
         </p:cxnSp>
-        <mc:AlternateContent xmlns:mc="http://schemas.openxmlformats.org/markup-compatibility/2006">
-          <mc:Choice xmlns:a14="http://schemas.microsoft.com/office/drawing/2010/main" Requires="a14">
+        <mc:AlternateContent xmlns:mc="http://schemas.openxmlformats.org/markup-compatibility/2006" xmlns:a14="http://schemas.microsoft.com/office/drawing/2010/main">
+          <mc:Choice Requires="a14">
             <p:sp>
               <p:nvSpPr>
                 <p:cNvPr id="89" name="Textfeld 88">
@@ -4541,6 +4545,7 @@
                 </a:bodyPr>
                 <a:lstStyle/>
                 <a:p>
+                  <a:pPr/>
                   <a14:m>
                     <m:oMathPara xmlns:m="http://schemas.openxmlformats.org/officeDocument/2006/math">
                       <m:oMathParaPr>
@@ -4550,7 +4555,7 @@
                         <m:sSub>
                           <m:sSubPr>
                             <m:ctrlPr>
-                              <a:rPr lang="de-DE" b="0" i="0" dirty="0" smtClean="0">
+                              <a:rPr lang="de-DE" b="0" i="1" dirty="0" smtClean="0">
                                 <a:latin typeface="Cambria Math" panose="02040503050406030204" pitchFamily="18" charset="0"/>
                               </a:rPr>
                             </m:ctrlPr>
@@ -4583,7 +4588,7 @@
               </p:txBody>
             </p:sp>
           </mc:Choice>
-          <mc:Fallback>
+          <mc:Fallback xmlns="">
             <p:sp>
               <p:nvSpPr>
                 <p:cNvPr id="89" name="Textfeld 88">
@@ -4628,8 +4633,8 @@
             </p:sp>
           </mc:Fallback>
         </mc:AlternateContent>
-        <mc:AlternateContent xmlns:mc="http://schemas.openxmlformats.org/markup-compatibility/2006">
-          <mc:Choice xmlns:a14="http://schemas.microsoft.com/office/drawing/2010/main" Requires="a14">
+        <mc:AlternateContent xmlns:mc="http://schemas.openxmlformats.org/markup-compatibility/2006" xmlns:a14="http://schemas.microsoft.com/office/drawing/2010/main">
+          <mc:Choice Requires="a14">
             <p:sp>
               <p:nvSpPr>
                 <p:cNvPr id="90" name="Textfeld 89">
@@ -4658,6 +4663,7 @@
                 </a:bodyPr>
                 <a:lstStyle/>
                 <a:p>
+                  <a:pPr/>
                   <a14:m>
                     <m:oMathPara xmlns:m="http://schemas.openxmlformats.org/officeDocument/2006/math">
                       <m:oMathParaPr>
@@ -4667,7 +4673,7 @@
                         <m:sSub>
                           <m:sSubPr>
                             <m:ctrlPr>
-                              <a:rPr lang="de-DE" dirty="0">
+                              <a:rPr lang="de-DE" i="1" dirty="0">
                                 <a:latin typeface="Cambria Math" panose="02040503050406030204" pitchFamily="18" charset="0"/>
                               </a:rPr>
                             </m:ctrlPr>
@@ -4700,7 +4706,7 @@
               </p:txBody>
             </p:sp>
           </mc:Choice>
-          <mc:Fallback>
+          <mc:Fallback xmlns="">
             <p:sp>
               <p:nvSpPr>
                 <p:cNvPr id="90" name="Textfeld 89">
@@ -4745,8 +4751,8 @@
             </p:sp>
           </mc:Fallback>
         </mc:AlternateContent>
-        <mc:AlternateContent xmlns:mc="http://schemas.openxmlformats.org/markup-compatibility/2006">
-          <mc:Choice xmlns:a14="http://schemas.microsoft.com/office/drawing/2010/main" Requires="a14">
+        <mc:AlternateContent xmlns:mc="http://schemas.openxmlformats.org/markup-compatibility/2006" xmlns:a14="http://schemas.microsoft.com/office/drawing/2010/main">
+          <mc:Choice Requires="a14">
             <p:sp>
               <p:nvSpPr>
                 <p:cNvPr id="91" name="Textfeld 90">
@@ -4775,6 +4781,7 @@
                 </a:bodyPr>
                 <a:lstStyle/>
                 <a:p>
+                  <a:pPr/>
                   <a14:m>
                     <m:oMathPara xmlns:m="http://schemas.openxmlformats.org/officeDocument/2006/math">
                       <m:oMathParaPr>
@@ -4784,7 +4791,7 @@
                         <m:sSub>
                           <m:sSubPr>
                             <m:ctrlPr>
-                              <a:rPr lang="de-DE" b="0" i="0" dirty="0" smtClean="0">
+                              <a:rPr lang="de-DE" b="0" i="1" dirty="0" smtClean="0">
                                 <a:latin typeface="Cambria Math" panose="02040503050406030204" pitchFamily="18" charset="0"/>
                               </a:rPr>
                             </m:ctrlPr>
@@ -4817,7 +4824,7 @@
               </p:txBody>
             </p:sp>
           </mc:Choice>
-          <mc:Fallback>
+          <mc:Fallback xmlns="">
             <p:sp>
               <p:nvSpPr>
                 <p:cNvPr id="91" name="Textfeld 90">
@@ -5104,8 +5111,8 @@
             </a:fontRef>
           </p:style>
         </p:cxnSp>
-        <mc:AlternateContent xmlns:mc="http://schemas.openxmlformats.org/markup-compatibility/2006">
-          <mc:Choice xmlns:a14="http://schemas.microsoft.com/office/drawing/2010/main" Requires="a14">
+        <mc:AlternateContent xmlns:mc="http://schemas.openxmlformats.org/markup-compatibility/2006" xmlns:a14="http://schemas.microsoft.com/office/drawing/2010/main">
+          <mc:Choice Requires="a14">
             <p:sp>
               <p:nvSpPr>
                 <p:cNvPr id="100" name="Textfeld 99">
@@ -5134,6 +5141,7 @@
                 </a:bodyPr>
                 <a:lstStyle/>
                 <a:p>
+                  <a:pPr/>
                   <a14:m>
                     <m:oMathPara xmlns:m="http://schemas.openxmlformats.org/officeDocument/2006/math">
                       <m:oMathParaPr>
@@ -5143,7 +5151,7 @@
                         <m:sSub>
                           <m:sSubPr>
                             <m:ctrlPr>
-                              <a:rPr lang="de-DE" b="0" i="0" dirty="0" smtClean="0">
+                              <a:rPr lang="de-DE" b="0" i="1" dirty="0" smtClean="0">
                                 <a:latin typeface="Cambria Math" panose="02040503050406030204" pitchFamily="18" charset="0"/>
                               </a:rPr>
                             </m:ctrlPr>
@@ -5176,7 +5184,7 @@
               </p:txBody>
             </p:sp>
           </mc:Choice>
-          <mc:Fallback>
+          <mc:Fallback xmlns="">
             <p:sp>
               <p:nvSpPr>
                 <p:cNvPr id="100" name="Textfeld 99">
@@ -5221,8 +5229,8 @@
             </p:sp>
           </mc:Fallback>
         </mc:AlternateContent>
-        <mc:AlternateContent xmlns:mc="http://schemas.openxmlformats.org/markup-compatibility/2006">
-          <mc:Choice xmlns:a14="http://schemas.microsoft.com/office/drawing/2010/main" Requires="a14">
+        <mc:AlternateContent xmlns:mc="http://schemas.openxmlformats.org/markup-compatibility/2006" xmlns:a14="http://schemas.microsoft.com/office/drawing/2010/main">
+          <mc:Choice Requires="a14">
             <p:sp>
               <p:nvSpPr>
                 <p:cNvPr id="101" name="Textfeld 100">
@@ -5251,6 +5259,7 @@
                 </a:bodyPr>
                 <a:lstStyle/>
                 <a:p>
+                  <a:pPr/>
                   <a14:m>
                     <m:oMathPara xmlns:m="http://schemas.openxmlformats.org/officeDocument/2006/math">
                       <m:oMathParaPr>
@@ -5260,7 +5269,7 @@
                         <m:sSub>
                           <m:sSubPr>
                             <m:ctrlPr>
-                              <a:rPr lang="de-DE" dirty="0" smtClean="0">
+                              <a:rPr lang="de-DE" i="1" dirty="0" smtClean="0">
                                 <a:latin typeface="Cambria Math" panose="02040503050406030204" pitchFamily="18" charset="0"/>
                               </a:rPr>
                             </m:ctrlPr>
@@ -5293,7 +5302,7 @@
               </p:txBody>
             </p:sp>
           </mc:Choice>
-          <mc:Fallback>
+          <mc:Fallback xmlns="">
             <p:sp>
               <p:nvSpPr>
                 <p:cNvPr id="101" name="Textfeld 100">
@@ -5338,8 +5347,8 @@
             </p:sp>
           </mc:Fallback>
         </mc:AlternateContent>
-        <mc:AlternateContent xmlns:mc="http://schemas.openxmlformats.org/markup-compatibility/2006">
-          <mc:Choice xmlns:a14="http://schemas.microsoft.com/office/drawing/2010/main" Requires="a14">
+        <mc:AlternateContent xmlns:mc="http://schemas.openxmlformats.org/markup-compatibility/2006" xmlns:a14="http://schemas.microsoft.com/office/drawing/2010/main">
+          <mc:Choice Requires="a14">
             <p:sp>
               <p:nvSpPr>
                 <p:cNvPr id="102" name="Textfeld 101">
@@ -5368,6 +5377,7 @@
                 </a:bodyPr>
                 <a:lstStyle/>
                 <a:p>
+                  <a:pPr/>
                   <a14:m>
                     <m:oMathPara xmlns:m="http://schemas.openxmlformats.org/officeDocument/2006/math">
                       <m:oMathParaPr>
@@ -5377,7 +5387,7 @@
                         <m:sSub>
                           <m:sSubPr>
                             <m:ctrlPr>
-                              <a:rPr lang="de-DE" b="0" i="0" dirty="0" smtClean="0">
+                              <a:rPr lang="de-DE" b="0" i="1" dirty="0" smtClean="0">
                                 <a:latin typeface="Cambria Math" panose="02040503050406030204" pitchFamily="18" charset="0"/>
                               </a:rPr>
                             </m:ctrlPr>
@@ -5410,7 +5420,7 @@
               </p:txBody>
             </p:sp>
           </mc:Choice>
-          <mc:Fallback>
+          <mc:Fallback xmlns="">
             <p:sp>
               <p:nvSpPr>
                 <p:cNvPr id="102" name="Textfeld 101">
@@ -5652,8 +5662,8 @@
             </a:fontRef>
           </p:style>
         </p:cxnSp>
-        <mc:AlternateContent xmlns:mc="http://schemas.openxmlformats.org/markup-compatibility/2006">
-          <mc:Choice xmlns:a14="http://schemas.microsoft.com/office/drawing/2010/main" Requires="a14">
+        <mc:AlternateContent xmlns:mc="http://schemas.openxmlformats.org/markup-compatibility/2006" xmlns:a14="http://schemas.microsoft.com/office/drawing/2010/main">
+          <mc:Choice Requires="a14">
             <p:sp>
               <p:nvSpPr>
                 <p:cNvPr id="108" name="Textfeld 107">
@@ -5682,6 +5692,7 @@
                 </a:bodyPr>
                 <a:lstStyle/>
                 <a:p>
+                  <a:pPr/>
                   <a14:m>
                     <m:oMathPara xmlns:m="http://schemas.openxmlformats.org/officeDocument/2006/math">
                       <m:oMathParaPr>
@@ -5691,7 +5702,7 @@
                         <m:sSub>
                           <m:sSubPr>
                             <m:ctrlPr>
-                              <a:rPr lang="de-DE" b="0" i="0" dirty="0" smtClean="0">
+                              <a:rPr lang="de-DE" b="0" i="1" dirty="0" smtClean="0">
                                 <a:latin typeface="Cambria Math" panose="02040503050406030204" pitchFamily="18" charset="0"/>
                               </a:rPr>
                             </m:ctrlPr>
@@ -5727,7 +5738,7 @@
               </p:txBody>
             </p:sp>
           </mc:Choice>
-          <mc:Fallback>
+          <mc:Fallback xmlns="">
             <p:sp>
               <p:nvSpPr>
                 <p:cNvPr id="108" name="Textfeld 107">
@@ -5772,8 +5783,8 @@
             </p:sp>
           </mc:Fallback>
         </mc:AlternateContent>
-        <mc:AlternateContent xmlns:mc="http://schemas.openxmlformats.org/markup-compatibility/2006">
-          <mc:Choice xmlns:a14="http://schemas.microsoft.com/office/drawing/2010/main" Requires="a14">
+        <mc:AlternateContent xmlns:mc="http://schemas.openxmlformats.org/markup-compatibility/2006" xmlns:a14="http://schemas.microsoft.com/office/drawing/2010/main">
+          <mc:Choice Requires="a14">
             <p:sp>
               <p:nvSpPr>
                 <p:cNvPr id="109" name="Textfeld 108">
@@ -5802,6 +5813,7 @@
                 </a:bodyPr>
                 <a:lstStyle/>
                 <a:p>
+                  <a:pPr/>
                   <a14:m>
                     <m:oMathPara xmlns:m="http://schemas.openxmlformats.org/officeDocument/2006/math">
                       <m:oMathParaPr>
@@ -5811,7 +5823,7 @@
                         <m:sSub>
                           <m:sSubPr>
                             <m:ctrlPr>
-                              <a:rPr lang="de-DE" dirty="0" smtClean="0">
+                              <a:rPr lang="de-DE" i="1" dirty="0" smtClean="0">
                                 <a:latin typeface="Cambria Math" panose="02040503050406030204" pitchFamily="18" charset="0"/>
                               </a:rPr>
                             </m:ctrlPr>
@@ -5847,7 +5859,7 @@
               </p:txBody>
             </p:sp>
           </mc:Choice>
-          <mc:Fallback>
+          <mc:Fallback xmlns="">
             <p:sp>
               <p:nvSpPr>
                 <p:cNvPr id="109" name="Textfeld 108">
@@ -5892,8 +5904,8 @@
             </p:sp>
           </mc:Fallback>
         </mc:AlternateContent>
-        <mc:AlternateContent xmlns:mc="http://schemas.openxmlformats.org/markup-compatibility/2006">
-          <mc:Choice xmlns:a14="http://schemas.microsoft.com/office/drawing/2010/main" Requires="a14">
+        <mc:AlternateContent xmlns:mc="http://schemas.openxmlformats.org/markup-compatibility/2006" xmlns:a14="http://schemas.microsoft.com/office/drawing/2010/main">
+          <mc:Choice Requires="a14">
             <p:sp>
               <p:nvSpPr>
                 <p:cNvPr id="110" name="Textfeld 109">
@@ -5922,6 +5934,7 @@
                 </a:bodyPr>
                 <a:lstStyle/>
                 <a:p>
+                  <a:pPr/>
                   <a14:m>
                     <m:oMathPara xmlns:m="http://schemas.openxmlformats.org/officeDocument/2006/math">
                       <m:oMathParaPr>
@@ -5931,7 +5944,7 @@
                         <m:sSub>
                           <m:sSubPr>
                             <m:ctrlPr>
-                              <a:rPr lang="de-DE" b="0" i="0" dirty="0" smtClean="0">
+                              <a:rPr lang="de-DE" b="0" i="1" dirty="0" smtClean="0">
                                 <a:latin typeface="Cambria Math" panose="02040503050406030204" pitchFamily="18" charset="0"/>
                               </a:rPr>
                             </m:ctrlPr>
@@ -5967,7 +5980,7 @@
               </p:txBody>
             </p:sp>
           </mc:Choice>
-          <mc:Fallback>
+          <mc:Fallback xmlns="">
             <p:sp>
               <p:nvSpPr>
                 <p:cNvPr id="110" name="Textfeld 109">
@@ -6292,8 +6305,8 @@
             </a:fontRef>
           </p:style>
         </p:cxnSp>
-        <mc:AlternateContent xmlns:mc="http://schemas.openxmlformats.org/markup-compatibility/2006">
-          <mc:Choice xmlns:a14="http://schemas.microsoft.com/office/drawing/2010/main" Requires="a14">
+        <mc:AlternateContent xmlns:mc="http://schemas.openxmlformats.org/markup-compatibility/2006" xmlns:a14="http://schemas.microsoft.com/office/drawing/2010/main">
+          <mc:Choice Requires="a14">
             <p:sp>
               <p:nvSpPr>
                 <p:cNvPr id="131" name="Textfeld 130">
@@ -6322,6 +6335,7 @@
                 </a:bodyPr>
                 <a:lstStyle/>
                 <a:p>
+                  <a:pPr/>
                   <a14:m>
                     <m:oMathPara xmlns:m="http://schemas.openxmlformats.org/officeDocument/2006/math">
                       <m:oMathParaPr>
@@ -6331,7 +6345,7 @@
                         <m:sSub>
                           <m:sSubPr>
                             <m:ctrlPr>
-                              <a:rPr lang="de-DE" b="0" i="0" dirty="0" smtClean="0">
+                              <a:rPr lang="de-DE" b="0" i="1" dirty="0" smtClean="0">
                                 <a:latin typeface="Cambria Math" panose="02040503050406030204" pitchFamily="18" charset="0"/>
                               </a:rPr>
                             </m:ctrlPr>
@@ -6364,7 +6378,7 @@
               </p:txBody>
             </p:sp>
           </mc:Choice>
-          <mc:Fallback>
+          <mc:Fallback xmlns="">
             <p:sp>
               <p:nvSpPr>
                 <p:cNvPr id="131" name="Textfeld 130">
@@ -6409,8 +6423,8 @@
             </p:sp>
           </mc:Fallback>
         </mc:AlternateContent>
-        <mc:AlternateContent xmlns:mc="http://schemas.openxmlformats.org/markup-compatibility/2006">
-          <mc:Choice xmlns:a14="http://schemas.microsoft.com/office/drawing/2010/main" Requires="a14">
+        <mc:AlternateContent xmlns:mc="http://schemas.openxmlformats.org/markup-compatibility/2006" xmlns:a14="http://schemas.microsoft.com/office/drawing/2010/main">
+          <mc:Choice Requires="a14">
             <p:sp>
               <p:nvSpPr>
                 <p:cNvPr id="132" name="Textfeld 131">
@@ -6439,6 +6453,7 @@
                 </a:bodyPr>
                 <a:lstStyle/>
                 <a:p>
+                  <a:pPr/>
                   <a14:m>
                     <m:oMathPara xmlns:m="http://schemas.openxmlformats.org/officeDocument/2006/math">
                       <m:oMathParaPr>
@@ -6448,7 +6463,7 @@
                         <m:sSub>
                           <m:sSubPr>
                             <m:ctrlPr>
-                              <a:rPr lang="de-DE" dirty="0" smtClean="0">
+                              <a:rPr lang="de-DE" i="1" dirty="0" smtClean="0">
                                 <a:latin typeface="Cambria Math" panose="02040503050406030204" pitchFamily="18" charset="0"/>
                               </a:rPr>
                             </m:ctrlPr>
@@ -6481,7 +6496,7 @@
               </p:txBody>
             </p:sp>
           </mc:Choice>
-          <mc:Fallback>
+          <mc:Fallback xmlns="">
             <p:sp>
               <p:nvSpPr>
                 <p:cNvPr id="132" name="Textfeld 131">
@@ -6526,8 +6541,8 @@
             </p:sp>
           </mc:Fallback>
         </mc:AlternateContent>
-        <mc:AlternateContent xmlns:mc="http://schemas.openxmlformats.org/markup-compatibility/2006">
-          <mc:Choice xmlns:a14="http://schemas.microsoft.com/office/drawing/2010/main" Requires="a14">
+        <mc:AlternateContent xmlns:mc="http://schemas.openxmlformats.org/markup-compatibility/2006" xmlns:a14="http://schemas.microsoft.com/office/drawing/2010/main">
+          <mc:Choice Requires="a14">
             <p:sp>
               <p:nvSpPr>
                 <p:cNvPr id="133" name="Textfeld 132">
@@ -6556,6 +6571,7 @@
                 </a:bodyPr>
                 <a:lstStyle/>
                 <a:p>
+                  <a:pPr/>
                   <a14:m>
                     <m:oMathPara xmlns:m="http://schemas.openxmlformats.org/officeDocument/2006/math">
                       <m:oMathParaPr>
@@ -6565,7 +6581,7 @@
                         <m:sSub>
                           <m:sSubPr>
                             <m:ctrlPr>
-                              <a:rPr lang="de-DE" b="0" i="0" dirty="0" smtClean="0">
+                              <a:rPr lang="de-DE" b="0" i="1" dirty="0" smtClean="0">
                                 <a:latin typeface="Cambria Math" panose="02040503050406030204" pitchFamily="18" charset="0"/>
                               </a:rPr>
                             </m:ctrlPr>
@@ -6598,7 +6614,7 @@
               </p:txBody>
             </p:sp>
           </mc:Choice>
-          <mc:Fallback>
+          <mc:Fallback xmlns="">
             <p:sp>
               <p:nvSpPr>
                 <p:cNvPr id="133" name="Textfeld 132">
@@ -6863,8 +6879,8 @@
           </a:fontRef>
         </p:style>
       </p:cxnSp>
-      <mc:AlternateContent xmlns:mc="http://schemas.openxmlformats.org/markup-compatibility/2006">
-        <mc:Choice xmlns:a14="http://schemas.microsoft.com/office/drawing/2010/main" Requires="a14">
+      <mc:AlternateContent xmlns:mc="http://schemas.openxmlformats.org/markup-compatibility/2006" xmlns:a14="http://schemas.microsoft.com/office/drawing/2010/main">
+        <mc:Choice Requires="a14">
           <p:sp>
             <p:nvSpPr>
               <p:cNvPr id="140" name="Textfeld 139">
@@ -6893,6 +6909,7 @@
               </a:bodyPr>
               <a:lstStyle/>
               <a:p>
+                <a:pPr/>
                 <a14:m>
                   <m:oMathPara xmlns:m="http://schemas.openxmlformats.org/officeDocument/2006/math">
                     <m:oMathParaPr>
@@ -6902,7 +6919,7 @@
                       <m:sSub>
                         <m:sSubPr>
                           <m:ctrlPr>
-                            <a:rPr lang="de-DE" b="0" i="0" dirty="0" smtClean="0">
+                            <a:rPr lang="de-DE" b="0" i="1" dirty="0" smtClean="0">
                               <a:latin typeface="Cambria Math" panose="02040503050406030204" pitchFamily="18" charset="0"/>
                             </a:rPr>
                           </m:ctrlPr>
@@ -6935,7 +6952,7 @@
             </p:txBody>
           </p:sp>
         </mc:Choice>
-        <mc:Fallback>
+        <mc:Fallback xmlns="">
           <p:sp>
             <p:nvSpPr>
               <p:cNvPr id="140" name="Textfeld 139">
@@ -6980,8 +6997,8 @@
           </p:sp>
         </mc:Fallback>
       </mc:AlternateContent>
-      <mc:AlternateContent xmlns:mc="http://schemas.openxmlformats.org/markup-compatibility/2006">
-        <mc:Choice xmlns:a14="http://schemas.microsoft.com/office/drawing/2010/main" Requires="a14">
+      <mc:AlternateContent xmlns:mc="http://schemas.openxmlformats.org/markup-compatibility/2006" xmlns:a14="http://schemas.microsoft.com/office/drawing/2010/main">
+        <mc:Choice Requires="a14">
           <p:sp>
             <p:nvSpPr>
               <p:cNvPr id="141" name="Textfeld 140">
@@ -7010,6 +7027,7 @@
               </a:bodyPr>
               <a:lstStyle/>
               <a:p>
+                <a:pPr/>
                 <a14:m>
                   <m:oMathPara xmlns:m="http://schemas.openxmlformats.org/officeDocument/2006/math">
                     <m:oMathParaPr>
@@ -7019,7 +7037,7 @@
                       <m:sSub>
                         <m:sSubPr>
                           <m:ctrlPr>
-                            <a:rPr lang="de-DE" dirty="0" smtClean="0">
+                            <a:rPr lang="de-DE" i="1" dirty="0" smtClean="0">
                               <a:latin typeface="Cambria Math" panose="02040503050406030204" pitchFamily="18" charset="0"/>
                             </a:rPr>
                           </m:ctrlPr>
@@ -7052,7 +7070,7 @@
             </p:txBody>
           </p:sp>
         </mc:Choice>
-        <mc:Fallback>
+        <mc:Fallback xmlns="">
           <p:sp>
             <p:nvSpPr>
               <p:cNvPr id="141" name="Textfeld 140">
@@ -7097,8 +7115,8 @@
           </p:sp>
         </mc:Fallback>
       </mc:AlternateContent>
-      <mc:AlternateContent xmlns:mc="http://schemas.openxmlformats.org/markup-compatibility/2006">
-        <mc:Choice xmlns:a14="http://schemas.microsoft.com/office/drawing/2010/main" Requires="a14">
+      <mc:AlternateContent xmlns:mc="http://schemas.openxmlformats.org/markup-compatibility/2006" xmlns:a14="http://schemas.microsoft.com/office/drawing/2010/main">
+        <mc:Choice Requires="a14">
           <p:sp>
             <p:nvSpPr>
               <p:cNvPr id="142" name="Textfeld 141">
@@ -7127,6 +7145,7 @@
               </a:bodyPr>
               <a:lstStyle/>
               <a:p>
+                <a:pPr/>
                 <a14:m>
                   <m:oMathPara xmlns:m="http://schemas.openxmlformats.org/officeDocument/2006/math">
                     <m:oMathParaPr>
@@ -7136,7 +7155,7 @@
                       <m:sSub>
                         <m:sSubPr>
                           <m:ctrlPr>
-                            <a:rPr lang="de-DE" b="0" i="0" smtClean="0">
+                            <a:rPr lang="de-DE" b="0" i="1" smtClean="0">
                               <a:latin typeface="Cambria Math" panose="02040503050406030204" pitchFamily="18" charset="0"/>
                             </a:rPr>
                           </m:ctrlPr>
@@ -7169,7 +7188,7 @@
             </p:txBody>
           </p:sp>
         </mc:Choice>
-        <mc:Fallback>
+        <mc:Fallback xmlns="">
           <p:sp>
             <p:nvSpPr>
               <p:cNvPr id="142" name="Textfeld 141">
@@ -7346,10 +7365,10 @@
         </p:nvGrpSpPr>
         <p:grpSpPr>
           <a:xfrm>
-            <a:off x="313626" y="-16769"/>
-            <a:ext cx="6800406" cy="11938333"/>
-            <a:chOff x="789114" y="1922876"/>
-            <a:chExt cx="5256318" cy="9627362"/>
+            <a:off x="506562" y="-16769"/>
+            <a:ext cx="6607470" cy="11938334"/>
+            <a:chOff x="938242" y="1922876"/>
+            <a:chExt cx="5107190" cy="9627363"/>
           </a:xfrm>
         </p:grpSpPr>
         <p:sp>
@@ -7682,10 +7701,10 @@
           </p:nvGrpSpPr>
           <p:grpSpPr>
             <a:xfrm>
-              <a:off x="789114" y="9036950"/>
-              <a:ext cx="3886122" cy="2513288"/>
-              <a:chOff x="2721570" y="6191162"/>
-              <a:chExt cx="2337279" cy="1511599"/>
+              <a:off x="938242" y="9025357"/>
+              <a:ext cx="3736994" cy="2524882"/>
+              <a:chOff x="2811262" y="6184189"/>
+              <a:chExt cx="2247587" cy="1518572"/>
             </a:xfrm>
           </p:grpSpPr>
           <p:cxnSp>
@@ -7710,7 +7729,7 @@
               <a:prstGeom prst="straightConnector1">
                 <a:avLst/>
               </a:prstGeom>
-              <a:ln w="38100">
+              <a:ln w="76200">
                 <a:solidFill>
                   <a:srgbClr val="FF0000"/>
                 </a:solidFill>
@@ -7754,7 +7773,7 @@
               <a:prstGeom prst="straightConnector1">
                 <a:avLst/>
               </a:prstGeom>
-              <a:ln w="38100">
+              <a:ln w="76200">
                 <a:solidFill>
                   <a:schemeClr val="accent6"/>
                 </a:solidFill>
@@ -7792,7 +7811,7 @@
                 </p:nvSpPr>
                 <p:spPr>
                   <a:xfrm flipH="1">
-                    <a:off x="2940973" y="6191162"/>
+                    <a:off x="3238101" y="6184189"/>
                     <a:ext cx="275424" cy="351709"/>
                   </a:xfrm>
                   <a:prstGeom prst="rect">
@@ -7869,7 +7888,7 @@
                 </p:nvSpPr>
                 <p:spPr>
                   <a:xfrm flipH="1">
-                    <a:off x="2940973" y="6191162"/>
+                    <a:off x="3238101" y="6184189"/>
                     <a:ext cx="275424" cy="351709"/>
                   </a:xfrm>
                   <a:prstGeom prst="rect">
@@ -7913,7 +7932,7 @@
                 </p:nvSpPr>
                 <p:spPr>
                   <a:xfrm flipH="1">
-                    <a:off x="2721570" y="6745006"/>
+                    <a:off x="2811262" y="6803980"/>
                     <a:ext cx="346982" cy="351709"/>
                   </a:xfrm>
                   <a:prstGeom prst="rect">
@@ -7990,7 +8009,7 @@
                 </p:nvSpPr>
                 <p:spPr>
                   <a:xfrm flipH="1">
-                    <a:off x="2721570" y="6745006"/>
+                    <a:off x="2811262" y="6803980"/>
                     <a:ext cx="346982" cy="351709"/>
                   </a:xfrm>
                   <a:prstGeom prst="rect">
@@ -8018,8 +8037,8 @@
               </p:sp>
             </mc:Fallback>
           </mc:AlternateContent>
-          <mc:AlternateContent xmlns:mc="http://schemas.openxmlformats.org/markup-compatibility/2006">
-            <mc:Choice xmlns:a14="http://schemas.microsoft.com/office/drawing/2010/main" Requires="a14">
+          <mc:AlternateContent xmlns:mc="http://schemas.openxmlformats.org/markup-compatibility/2006" xmlns:a14="http://schemas.microsoft.com/office/drawing/2010/main">
+            <mc:Choice Requires="a14">
               <p:sp>
                 <p:nvSpPr>
                   <p:cNvPr id="110" name="Textfeld 109">
@@ -8094,7 +8113,7 @@
                 </p:txBody>
               </p:sp>
             </mc:Choice>
-            <mc:Fallback>
+            <mc:Fallback xmlns="">
               <p:sp>
                 <p:nvSpPr>
                   <p:cNvPr id="110" name="Textfeld 109">
@@ -8161,7 +8180,7 @@
               <a:prstGeom prst="line">
                 <a:avLst/>
               </a:prstGeom>
-              <a:ln w="38100">
+              <a:ln w="76200">
                 <a:solidFill>
                   <a:srgbClr val="0070C0"/>
                 </a:solidFill>
@@ -8205,7 +8224,7 @@
               <a:prstGeom prst="straightConnector1">
                 <a:avLst/>
               </a:prstGeom>
-              <a:ln w="38100">
+              <a:ln w="76200">
                 <a:solidFill>
                   <a:srgbClr val="0070C0"/>
                 </a:solidFill>
@@ -8369,9 +8388,9 @@
           <p:grpSpPr>
             <a:xfrm>
               <a:off x="1510204" y="1922876"/>
-              <a:ext cx="3165032" cy="2532620"/>
+              <a:ext cx="3165032" cy="2286704"/>
               <a:chOff x="1476322" y="277175"/>
-              <a:chExt cx="3165032" cy="2532620"/>
+              <a:chExt cx="3165032" cy="2286704"/>
             </a:xfrm>
           </p:grpSpPr>
           <p:cxnSp>
@@ -8397,7 +8416,7 @@
               <a:prstGeom prst="straightConnector1">
                 <a:avLst/>
               </a:prstGeom>
-              <a:ln w="38100">
+              <a:ln w="76200">
                 <a:solidFill>
                   <a:srgbClr val="FF0000"/>
                 </a:solidFill>
@@ -8441,7 +8460,7 @@
               <a:prstGeom prst="straightConnector1">
                 <a:avLst/>
               </a:prstGeom>
-              <a:ln w="38100">
+              <a:ln w="76200">
                 <a:solidFill>
                   <a:schemeClr val="accent6"/>
                 </a:solidFill>
@@ -8463,8 +8482,8 @@
               </a:fontRef>
             </p:style>
           </p:cxnSp>
-          <mc:AlternateContent xmlns:mc="http://schemas.openxmlformats.org/markup-compatibility/2006">
-            <mc:Choice xmlns:a14="http://schemas.microsoft.com/office/drawing/2010/main" Requires="a14">
+          <mc:AlternateContent xmlns:mc="http://schemas.openxmlformats.org/markup-compatibility/2006" xmlns:a14="http://schemas.microsoft.com/office/drawing/2010/main">
+            <mc:Choice Requires="a14">
               <p:sp>
                 <p:nvSpPr>
                   <p:cNvPr id="140" name="Textfeld 139">
@@ -8536,7 +8555,7 @@
                 </p:txBody>
               </p:sp>
             </mc:Choice>
-            <mc:Fallback>
+            <mc:Fallback xmlns="">
               <p:sp>
                 <p:nvSpPr>
                   <p:cNvPr id="140" name="Textfeld 139">
@@ -8597,7 +8616,7 @@
                 </p:nvSpPr>
                 <p:spPr>
                   <a:xfrm flipH="1">
-                    <a:off x="1781486" y="2225020"/>
+                    <a:off x="3315726" y="1979104"/>
                     <a:ext cx="576916" cy="584775"/>
                   </a:xfrm>
                   <a:prstGeom prst="rect">
@@ -8671,7 +8690,7 @@
                 </p:nvSpPr>
                 <p:spPr>
                   <a:xfrm flipH="1">
-                    <a:off x="1781486" y="2225020"/>
+                    <a:off x="3315726" y="1979104"/>
                     <a:ext cx="576916" cy="584775"/>
                   </a:xfrm>
                   <a:prstGeom prst="rect">
@@ -8699,8 +8718,8 @@
               </p:sp>
             </mc:Fallback>
           </mc:AlternateContent>
-          <mc:AlternateContent xmlns:mc="http://schemas.openxmlformats.org/markup-compatibility/2006">
-            <mc:Choice xmlns:a14="http://schemas.microsoft.com/office/drawing/2010/main" Requires="a14">
+          <mc:AlternateContent xmlns:mc="http://schemas.openxmlformats.org/markup-compatibility/2006" xmlns:a14="http://schemas.microsoft.com/office/drawing/2010/main">
+            <mc:Choice Requires="a14">
               <p:sp>
                 <p:nvSpPr>
                   <p:cNvPr id="142" name="Textfeld 141">
@@ -8772,7 +8791,7 @@
                 </p:txBody>
               </p:sp>
             </mc:Choice>
-            <mc:Fallback>
+            <mc:Fallback xmlns="">
               <p:sp>
                 <p:nvSpPr>
                   <p:cNvPr id="142" name="Textfeld 141">
@@ -8832,14 +8851,14 @@
               <p:nvPr/>
             </p:nvCxnSpPr>
             <p:spPr>
-              <a:xfrm flipH="1">
-                <a:off x="2295062" y="1664095"/>
-                <a:ext cx="698900" cy="768991"/>
+              <a:xfrm>
+                <a:off x="2965360" y="1667644"/>
+                <a:ext cx="391152" cy="444166"/>
               </a:xfrm>
               <a:prstGeom prst="straightConnector1">
                 <a:avLst/>
               </a:prstGeom>
-              <a:ln w="38100">
+              <a:ln w="76200">
                 <a:solidFill>
                   <a:srgbClr val="0070C0"/>
                 </a:solidFill>
@@ -8883,7 +8902,7 @@
               <a:prstGeom prst="line">
                 <a:avLst/>
               </a:prstGeom>
-              <a:ln w="38100">
+              <a:ln w="76200">
                 <a:solidFill>
                   <a:srgbClr val="00B050"/>
                 </a:solidFill>
@@ -9074,7 +9093,7 @@
                 <a:prstGeom prst="straightConnector1">
                   <a:avLst/>
                 </a:prstGeom>
-                <a:ln w="38100">
+                <a:ln w="76200">
                   <a:solidFill>
                     <a:srgbClr val="FF0000"/>
                   </a:solidFill>
@@ -9118,7 +9137,7 @@
                 <a:prstGeom prst="straightConnector1">
                   <a:avLst/>
                 </a:prstGeom>
-                <a:ln w="38100">
+                <a:ln w="76200">
                   <a:solidFill>
                     <a:schemeClr val="accent6"/>
                   </a:solidFill>
@@ -9140,8 +9159,8 @@
                 </a:fontRef>
               </p:style>
             </p:cxnSp>
-            <mc:AlternateContent xmlns:mc="http://schemas.openxmlformats.org/markup-compatibility/2006">
-              <mc:Choice xmlns:a14="http://schemas.microsoft.com/office/drawing/2010/main" Requires="a14">
+            <mc:AlternateContent xmlns:mc="http://schemas.openxmlformats.org/markup-compatibility/2006" xmlns:a14="http://schemas.microsoft.com/office/drawing/2010/main">
+              <mc:Choice Requires="a14">
                 <p:sp>
                   <p:nvSpPr>
                     <p:cNvPr id="24" name="Textfeld 23">
@@ -9213,7 +9232,7 @@
                   </p:txBody>
                 </p:sp>
               </mc:Choice>
-              <mc:Fallback>
+              <mc:Fallback xmlns="">
                 <p:sp>
                   <p:nvSpPr>
                     <p:cNvPr id="24" name="Textfeld 23">
@@ -9258,8 +9277,8 @@
                 </p:sp>
               </mc:Fallback>
             </mc:AlternateContent>
-            <mc:AlternateContent xmlns:mc="http://schemas.openxmlformats.org/markup-compatibility/2006">
-              <mc:Choice xmlns:a14="http://schemas.microsoft.com/office/drawing/2010/main" Requires="a14">
+            <mc:AlternateContent xmlns:mc="http://schemas.openxmlformats.org/markup-compatibility/2006" xmlns:a14="http://schemas.microsoft.com/office/drawing/2010/main">
+              <mc:Choice Requires="a14">
                 <p:sp>
                   <p:nvSpPr>
                     <p:cNvPr id="25" name="Textfeld 24">
@@ -9331,7 +9350,7 @@
                   </p:txBody>
                 </p:sp>
               </mc:Choice>
-              <mc:Fallback>
+              <mc:Fallback xmlns="">
                 <p:sp>
                   <p:nvSpPr>
                     <p:cNvPr id="25" name="Textfeld 24">
@@ -9376,8 +9395,8 @@
                 </p:sp>
               </mc:Fallback>
             </mc:AlternateContent>
-            <mc:AlternateContent xmlns:mc="http://schemas.openxmlformats.org/markup-compatibility/2006">
-              <mc:Choice xmlns:a14="http://schemas.microsoft.com/office/drawing/2010/main" Requires="a14">
+            <mc:AlternateContent xmlns:mc="http://schemas.openxmlformats.org/markup-compatibility/2006" xmlns:a14="http://schemas.microsoft.com/office/drawing/2010/main">
+              <mc:Choice Requires="a14">
                 <p:sp>
                   <p:nvSpPr>
                     <p:cNvPr id="26" name="Textfeld 25">
@@ -9449,7 +9468,7 @@
                   </p:txBody>
                 </p:sp>
               </mc:Choice>
-              <mc:Fallback>
+              <mc:Fallback xmlns="">
                 <p:sp>
                   <p:nvSpPr>
                     <p:cNvPr id="26" name="Textfeld 25">
@@ -9516,7 +9535,7 @@
                 <a:prstGeom prst="line">
                   <a:avLst/>
                 </a:prstGeom>
-                <a:ln w="38100">
+                <a:ln w="76200">
                   <a:solidFill>
                     <a:srgbClr val="0070C0"/>
                   </a:solidFill>
@@ -9560,7 +9579,7 @@
                 <a:prstGeom prst="straightConnector1">
                   <a:avLst/>
                 </a:prstGeom>
-                <a:ln w="38100">
+                <a:ln w="76200">
                   <a:solidFill>
                     <a:srgbClr val="0070C0"/>
                   </a:solidFill>
@@ -9583,8 +9602,8 @@
               </p:style>
             </p:cxnSp>
           </p:grpSp>
-          <mc:AlternateContent xmlns:mc="http://schemas.openxmlformats.org/markup-compatibility/2006">
-            <mc:Choice xmlns:a14="http://schemas.microsoft.com/office/drawing/2010/main" Requires="a14">
+          <mc:AlternateContent xmlns:mc="http://schemas.openxmlformats.org/markup-compatibility/2006" xmlns:a14="http://schemas.microsoft.com/office/drawing/2010/main">
+            <mc:Choice Requires="a14">
               <p:sp>
                 <p:nvSpPr>
                   <p:cNvPr id="16" name="Textfeld 15">
@@ -9656,7 +9675,7 @@
                 </p:txBody>
               </p:sp>
             </mc:Choice>
-            <mc:Fallback>
+            <mc:Fallback xmlns="">
               <p:sp>
                 <p:nvSpPr>
                   <p:cNvPr id="16" name="Textfeld 15">
@@ -9821,7 +9840,7 @@
                 <a:prstGeom prst="straightConnector1">
                   <a:avLst/>
                 </a:prstGeom>
-                <a:ln w="38100">
+                <a:ln w="76200">
                   <a:solidFill>
                     <a:srgbClr val="FF0000"/>
                   </a:solidFill>
@@ -9865,7 +9884,7 @@
                 <a:prstGeom prst="straightConnector1">
                   <a:avLst/>
                 </a:prstGeom>
-                <a:ln w="38100">
+                <a:ln w="76200">
                   <a:solidFill>
                     <a:schemeClr val="accent6"/>
                   </a:solidFill>
@@ -9887,8 +9906,8 @@
                 </a:fontRef>
               </p:style>
             </p:cxnSp>
-            <mc:AlternateContent xmlns:mc="http://schemas.openxmlformats.org/markup-compatibility/2006">
-              <mc:Choice xmlns:a14="http://schemas.microsoft.com/office/drawing/2010/main" Requires="a14">
+            <mc:AlternateContent xmlns:mc="http://schemas.openxmlformats.org/markup-compatibility/2006" xmlns:a14="http://schemas.microsoft.com/office/drawing/2010/main">
+              <mc:Choice Requires="a14">
                 <p:sp>
                   <p:nvSpPr>
                     <p:cNvPr id="100" name="Textfeld 99">
@@ -9960,7 +9979,7 @@
                   </p:txBody>
                 </p:sp>
               </mc:Choice>
-              <mc:Fallback>
+              <mc:Fallback xmlns="">
                 <p:sp>
                   <p:nvSpPr>
                     <p:cNvPr id="100" name="Textfeld 99">
@@ -10005,8 +10024,8 @@
                 </p:sp>
               </mc:Fallback>
             </mc:AlternateContent>
-            <mc:AlternateContent xmlns:mc="http://schemas.openxmlformats.org/markup-compatibility/2006">
-              <mc:Choice xmlns:a14="http://schemas.microsoft.com/office/drawing/2010/main" Requires="a14">
+            <mc:AlternateContent xmlns:mc="http://schemas.openxmlformats.org/markup-compatibility/2006" xmlns:a14="http://schemas.microsoft.com/office/drawing/2010/main">
+              <mc:Choice Requires="a14">
                 <p:sp>
                   <p:nvSpPr>
                     <p:cNvPr id="101" name="Textfeld 100">
@@ -10078,7 +10097,7 @@
                   </p:txBody>
                 </p:sp>
               </mc:Choice>
-              <mc:Fallback>
+              <mc:Fallback xmlns="">
                 <p:sp>
                   <p:nvSpPr>
                     <p:cNvPr id="101" name="Textfeld 100">
@@ -10123,8 +10142,8 @@
                 </p:sp>
               </mc:Fallback>
             </mc:AlternateContent>
-            <mc:AlternateContent xmlns:mc="http://schemas.openxmlformats.org/markup-compatibility/2006">
-              <mc:Choice xmlns:a14="http://schemas.microsoft.com/office/drawing/2010/main" Requires="a14">
+            <mc:AlternateContent xmlns:mc="http://schemas.openxmlformats.org/markup-compatibility/2006" xmlns:a14="http://schemas.microsoft.com/office/drawing/2010/main">
+              <mc:Choice Requires="a14">
                 <p:sp>
                   <p:nvSpPr>
                     <p:cNvPr id="102" name="Textfeld 101">
@@ -10196,7 +10215,7 @@
                   </p:txBody>
                 </p:sp>
               </mc:Choice>
-              <mc:Fallback>
+              <mc:Fallback xmlns="">
                 <p:sp>
                   <p:nvSpPr>
                     <p:cNvPr id="102" name="Textfeld 101">
@@ -10263,7 +10282,7 @@
                 <a:prstGeom prst="line">
                   <a:avLst/>
                 </a:prstGeom>
-                <a:ln w="38100">
+                <a:ln w="76200">
                   <a:solidFill>
                     <a:srgbClr val="0070C0"/>
                   </a:solidFill>
@@ -10307,7 +10326,7 @@
                 <a:prstGeom prst="straightConnector1">
                   <a:avLst/>
                 </a:prstGeom>
-                <a:ln w="38100">
+                <a:ln w="76200">
                   <a:solidFill>
                     <a:srgbClr val="0070C0"/>
                   </a:solidFill>
@@ -10330,8 +10349,8 @@
               </p:style>
             </p:cxnSp>
           </p:grpSp>
-          <mc:AlternateContent xmlns:mc="http://schemas.openxmlformats.org/markup-compatibility/2006">
-            <mc:Choice xmlns:a14="http://schemas.microsoft.com/office/drawing/2010/main" Requires="a14">
+          <mc:AlternateContent xmlns:mc="http://schemas.openxmlformats.org/markup-compatibility/2006" xmlns:a14="http://schemas.microsoft.com/office/drawing/2010/main">
+            <mc:Choice Requires="a14">
               <p:sp>
                 <p:nvSpPr>
                   <p:cNvPr id="18" name="Textfeld 17">
@@ -10403,7 +10422,7 @@
                 </p:txBody>
               </p:sp>
             </mc:Choice>
-            <mc:Fallback>
+            <mc:Fallback xmlns="">
               <p:sp>
                 <p:nvSpPr>
                   <p:cNvPr id="18" name="Textfeld 17">
@@ -10980,8 +10999,8 @@
               </a:fontRef>
             </p:style>
           </p:cxnSp>
-          <mc:AlternateContent xmlns:mc="http://schemas.openxmlformats.org/markup-compatibility/2006">
-            <mc:Choice xmlns:a14="http://schemas.microsoft.com/office/drawing/2010/main" Requires="a14">
+          <mc:AlternateContent xmlns:mc="http://schemas.openxmlformats.org/markup-compatibility/2006" xmlns:a14="http://schemas.microsoft.com/office/drawing/2010/main">
+            <mc:Choice Requires="a14">
               <p:sp>
                 <p:nvSpPr>
                   <p:cNvPr id="108" name="Textfeld 107">
@@ -11056,7 +11075,7 @@
                 </p:txBody>
               </p:sp>
             </mc:Choice>
-            <mc:Fallback>
+            <mc:Fallback xmlns="">
               <p:sp>
                 <p:nvSpPr>
                   <p:cNvPr id="108" name="Textfeld 107">
@@ -11101,8 +11120,8 @@
               </p:sp>
             </mc:Fallback>
           </mc:AlternateContent>
-          <mc:AlternateContent xmlns:mc="http://schemas.openxmlformats.org/markup-compatibility/2006">
-            <mc:Choice xmlns:a14="http://schemas.microsoft.com/office/drawing/2010/main" Requires="a14">
+          <mc:AlternateContent xmlns:mc="http://schemas.openxmlformats.org/markup-compatibility/2006" xmlns:a14="http://schemas.microsoft.com/office/drawing/2010/main">
+            <mc:Choice Requires="a14">
               <p:sp>
                 <p:nvSpPr>
                   <p:cNvPr id="109" name="Textfeld 108">
@@ -11177,7 +11196,7 @@
                 </p:txBody>
               </p:sp>
             </mc:Choice>
-            <mc:Fallback>
+            <mc:Fallback xmlns="">
               <p:sp>
                 <p:nvSpPr>
                   <p:cNvPr id="109" name="Textfeld 108">
@@ -11222,8 +11241,8 @@
               </p:sp>
             </mc:Fallback>
           </mc:AlternateContent>
-          <mc:AlternateContent xmlns:mc="http://schemas.openxmlformats.org/markup-compatibility/2006">
-            <mc:Choice xmlns:a14="http://schemas.microsoft.com/office/drawing/2010/main" Requires="a14">
+          <mc:AlternateContent xmlns:mc="http://schemas.openxmlformats.org/markup-compatibility/2006" xmlns:a14="http://schemas.microsoft.com/office/drawing/2010/main">
+            <mc:Choice Requires="a14">
               <p:sp>
                 <p:nvSpPr>
                   <p:cNvPr id="110" name="Textfeld 109">
@@ -11298,7 +11317,7 @@
                 </p:txBody>
               </p:sp>
             </mc:Choice>
-            <mc:Fallback>
+            <mc:Fallback xmlns="">
               <p:sp>
                 <p:nvSpPr>
                   <p:cNvPr id="110" name="Textfeld 109">
@@ -11667,8 +11686,8 @@
               </a:fontRef>
             </p:style>
           </p:cxnSp>
-          <mc:AlternateContent xmlns:mc="http://schemas.openxmlformats.org/markup-compatibility/2006">
-            <mc:Choice xmlns:a14="http://schemas.microsoft.com/office/drawing/2010/main" Requires="a14">
+          <mc:AlternateContent xmlns:mc="http://schemas.openxmlformats.org/markup-compatibility/2006" xmlns:a14="http://schemas.microsoft.com/office/drawing/2010/main">
+            <mc:Choice Requires="a14">
               <p:sp>
                 <p:nvSpPr>
                   <p:cNvPr id="140" name="Textfeld 139">
@@ -11740,7 +11759,7 @@
                 </p:txBody>
               </p:sp>
             </mc:Choice>
-            <mc:Fallback>
+            <mc:Fallback xmlns="">
               <p:sp>
                 <p:nvSpPr>
                   <p:cNvPr id="140" name="Textfeld 139">
@@ -11785,8 +11804,8 @@
               </p:sp>
             </mc:Fallback>
           </mc:AlternateContent>
-          <mc:AlternateContent xmlns:mc="http://schemas.openxmlformats.org/markup-compatibility/2006">
-            <mc:Choice xmlns:a14="http://schemas.microsoft.com/office/drawing/2010/main" Requires="a14">
+          <mc:AlternateContent xmlns:mc="http://schemas.openxmlformats.org/markup-compatibility/2006" xmlns:a14="http://schemas.microsoft.com/office/drawing/2010/main">
+            <mc:Choice Requires="a14">
               <p:sp>
                 <p:nvSpPr>
                   <p:cNvPr id="141" name="Textfeld 140">
@@ -11858,7 +11877,7 @@
                 </p:txBody>
               </p:sp>
             </mc:Choice>
-            <mc:Fallback>
+            <mc:Fallback xmlns="">
               <p:sp>
                 <p:nvSpPr>
                   <p:cNvPr id="141" name="Textfeld 140">
@@ -11903,8 +11922,8 @@
               </p:sp>
             </mc:Fallback>
           </mc:AlternateContent>
-          <mc:AlternateContent xmlns:mc="http://schemas.openxmlformats.org/markup-compatibility/2006">
-            <mc:Choice xmlns:a14="http://schemas.microsoft.com/office/drawing/2010/main" Requires="a14">
+          <mc:AlternateContent xmlns:mc="http://schemas.openxmlformats.org/markup-compatibility/2006" xmlns:a14="http://schemas.microsoft.com/office/drawing/2010/main">
+            <mc:Choice Requires="a14">
               <p:sp>
                 <p:nvSpPr>
                   <p:cNvPr id="142" name="Textfeld 141">
@@ -11976,7 +11995,7 @@
                 </p:txBody>
               </p:sp>
             </mc:Choice>
-            <mc:Fallback>
+            <mc:Fallback xmlns="">
               <p:sp>
                 <p:nvSpPr>
                   <p:cNvPr id="142" name="Textfeld 141">
@@ -12344,8 +12363,8 @@
                 </a:fontRef>
               </p:style>
             </p:cxnSp>
-            <mc:AlternateContent xmlns:mc="http://schemas.openxmlformats.org/markup-compatibility/2006">
-              <mc:Choice xmlns:a14="http://schemas.microsoft.com/office/drawing/2010/main" Requires="a14">
+            <mc:AlternateContent xmlns:mc="http://schemas.openxmlformats.org/markup-compatibility/2006" xmlns:a14="http://schemas.microsoft.com/office/drawing/2010/main">
+              <mc:Choice Requires="a14">
                 <p:sp>
                   <p:nvSpPr>
                     <p:cNvPr id="24" name="Textfeld 23">
@@ -12417,7 +12436,7 @@
                   </p:txBody>
                 </p:sp>
               </mc:Choice>
-              <mc:Fallback>
+              <mc:Fallback xmlns="">
                 <p:sp>
                   <p:nvSpPr>
                     <p:cNvPr id="24" name="Textfeld 23">
@@ -12462,8 +12481,8 @@
                 </p:sp>
               </mc:Fallback>
             </mc:AlternateContent>
-            <mc:AlternateContent xmlns:mc="http://schemas.openxmlformats.org/markup-compatibility/2006">
-              <mc:Choice xmlns:a14="http://schemas.microsoft.com/office/drawing/2010/main" Requires="a14">
+            <mc:AlternateContent xmlns:mc="http://schemas.openxmlformats.org/markup-compatibility/2006" xmlns:a14="http://schemas.microsoft.com/office/drawing/2010/main">
+              <mc:Choice Requires="a14">
                 <p:sp>
                   <p:nvSpPr>
                     <p:cNvPr id="25" name="Textfeld 24">
@@ -12535,7 +12554,7 @@
                   </p:txBody>
                 </p:sp>
               </mc:Choice>
-              <mc:Fallback>
+              <mc:Fallback xmlns="">
                 <p:sp>
                   <p:nvSpPr>
                     <p:cNvPr id="25" name="Textfeld 24">
@@ -12580,8 +12599,8 @@
                 </p:sp>
               </mc:Fallback>
             </mc:AlternateContent>
-            <mc:AlternateContent xmlns:mc="http://schemas.openxmlformats.org/markup-compatibility/2006">
-              <mc:Choice xmlns:a14="http://schemas.microsoft.com/office/drawing/2010/main" Requires="a14">
+            <mc:AlternateContent xmlns:mc="http://schemas.openxmlformats.org/markup-compatibility/2006" xmlns:a14="http://schemas.microsoft.com/office/drawing/2010/main">
+              <mc:Choice Requires="a14">
                 <p:sp>
                   <p:nvSpPr>
                     <p:cNvPr id="26" name="Textfeld 25">
@@ -12653,7 +12672,7 @@
                   </p:txBody>
                 </p:sp>
               </mc:Choice>
-              <mc:Fallback>
+              <mc:Fallback xmlns="">
                 <p:sp>
                   <p:nvSpPr>
                     <p:cNvPr id="26" name="Textfeld 25">
@@ -12787,8 +12806,8 @@
               </p:style>
             </p:cxnSp>
           </p:grpSp>
-          <mc:AlternateContent xmlns:mc="http://schemas.openxmlformats.org/markup-compatibility/2006">
-            <mc:Choice xmlns:a14="http://schemas.microsoft.com/office/drawing/2010/main" Requires="a14">
+          <mc:AlternateContent xmlns:mc="http://schemas.openxmlformats.org/markup-compatibility/2006" xmlns:a14="http://schemas.microsoft.com/office/drawing/2010/main">
+            <mc:Choice Requires="a14">
               <p:sp>
                 <p:nvSpPr>
                   <p:cNvPr id="16" name="Textfeld 15">
@@ -12860,7 +12879,7 @@
                 </p:txBody>
               </p:sp>
             </mc:Choice>
-            <mc:Fallback>
+            <mc:Fallback xmlns="">
               <p:sp>
                 <p:nvSpPr>
                   <p:cNvPr id="16" name="Textfeld 15">
@@ -13091,8 +13110,8 @@
                 </a:fontRef>
               </p:style>
             </p:cxnSp>
-            <mc:AlternateContent xmlns:mc="http://schemas.openxmlformats.org/markup-compatibility/2006">
-              <mc:Choice xmlns:a14="http://schemas.microsoft.com/office/drawing/2010/main" Requires="a14">
+            <mc:AlternateContent xmlns:mc="http://schemas.openxmlformats.org/markup-compatibility/2006" xmlns:a14="http://schemas.microsoft.com/office/drawing/2010/main">
+              <mc:Choice Requires="a14">
                 <p:sp>
                   <p:nvSpPr>
                     <p:cNvPr id="100" name="Textfeld 99">
@@ -13164,7 +13183,7 @@
                   </p:txBody>
                 </p:sp>
               </mc:Choice>
-              <mc:Fallback>
+              <mc:Fallback xmlns="">
                 <p:sp>
                   <p:nvSpPr>
                     <p:cNvPr id="100" name="Textfeld 99">
@@ -13209,8 +13228,8 @@
                 </p:sp>
               </mc:Fallback>
             </mc:AlternateContent>
-            <mc:AlternateContent xmlns:mc="http://schemas.openxmlformats.org/markup-compatibility/2006">
-              <mc:Choice xmlns:a14="http://schemas.microsoft.com/office/drawing/2010/main" Requires="a14">
+            <mc:AlternateContent xmlns:mc="http://schemas.openxmlformats.org/markup-compatibility/2006" xmlns:a14="http://schemas.microsoft.com/office/drawing/2010/main">
+              <mc:Choice Requires="a14">
                 <p:sp>
                   <p:nvSpPr>
                     <p:cNvPr id="101" name="Textfeld 100">
@@ -13282,7 +13301,7 @@
                   </p:txBody>
                 </p:sp>
               </mc:Choice>
-              <mc:Fallback>
+              <mc:Fallback xmlns="">
                 <p:sp>
                   <p:nvSpPr>
                     <p:cNvPr id="101" name="Textfeld 100">
@@ -13327,8 +13346,8 @@
                 </p:sp>
               </mc:Fallback>
             </mc:AlternateContent>
-            <mc:AlternateContent xmlns:mc="http://schemas.openxmlformats.org/markup-compatibility/2006">
-              <mc:Choice xmlns:a14="http://schemas.microsoft.com/office/drawing/2010/main" Requires="a14">
+            <mc:AlternateContent xmlns:mc="http://schemas.openxmlformats.org/markup-compatibility/2006" xmlns:a14="http://schemas.microsoft.com/office/drawing/2010/main">
+              <mc:Choice Requires="a14">
                 <p:sp>
                   <p:nvSpPr>
                     <p:cNvPr id="102" name="Textfeld 101">
@@ -13400,7 +13419,7 @@
                   </p:txBody>
                 </p:sp>
               </mc:Choice>
-              <mc:Fallback>
+              <mc:Fallback xmlns="">
                 <p:sp>
                   <p:nvSpPr>
                     <p:cNvPr id="102" name="Textfeld 101">
@@ -13534,8 +13553,8 @@
               </p:style>
             </p:cxnSp>
           </p:grpSp>
-          <mc:AlternateContent xmlns:mc="http://schemas.openxmlformats.org/markup-compatibility/2006">
-            <mc:Choice xmlns:a14="http://schemas.microsoft.com/office/drawing/2010/main" Requires="a14">
+          <mc:AlternateContent xmlns:mc="http://schemas.openxmlformats.org/markup-compatibility/2006" xmlns:a14="http://schemas.microsoft.com/office/drawing/2010/main">
+            <mc:Choice Requires="a14">
               <p:sp>
                 <p:nvSpPr>
                   <p:cNvPr id="18" name="Textfeld 17">
@@ -13607,7 +13626,7 @@
                 </p:txBody>
               </p:sp>
             </mc:Choice>
-            <mc:Fallback>
+            <mc:Fallback xmlns="">
               <p:sp>
                 <p:nvSpPr>
                   <p:cNvPr id="18" name="Textfeld 17">
@@ -14184,8 +14203,8 @@
               </a:fontRef>
             </p:style>
           </p:cxnSp>
-          <mc:AlternateContent xmlns:mc="http://schemas.openxmlformats.org/markup-compatibility/2006">
-            <mc:Choice xmlns:a14="http://schemas.microsoft.com/office/drawing/2010/main" Requires="a14">
+          <mc:AlternateContent xmlns:mc="http://schemas.openxmlformats.org/markup-compatibility/2006" xmlns:a14="http://schemas.microsoft.com/office/drawing/2010/main">
+            <mc:Choice Requires="a14">
               <p:sp>
                 <p:nvSpPr>
                   <p:cNvPr id="24" name="Textfeld 23">
@@ -14257,7 +14276,7 @@
                 </p:txBody>
               </p:sp>
             </mc:Choice>
-            <mc:Fallback>
+            <mc:Fallback xmlns="">
               <p:sp>
                 <p:nvSpPr>
                   <p:cNvPr id="24" name="Textfeld 23">
@@ -14302,8 +14321,8 @@
               </p:sp>
             </mc:Fallback>
           </mc:AlternateContent>
-          <mc:AlternateContent xmlns:mc="http://schemas.openxmlformats.org/markup-compatibility/2006">
-            <mc:Choice xmlns:a14="http://schemas.microsoft.com/office/drawing/2010/main" Requires="a14">
+          <mc:AlternateContent xmlns:mc="http://schemas.openxmlformats.org/markup-compatibility/2006" xmlns:a14="http://schemas.microsoft.com/office/drawing/2010/main">
+            <mc:Choice Requires="a14">
               <p:sp>
                 <p:nvSpPr>
                   <p:cNvPr id="25" name="Textfeld 24">
@@ -14375,7 +14394,7 @@
                 </p:txBody>
               </p:sp>
             </mc:Choice>
-            <mc:Fallback>
+            <mc:Fallback xmlns="">
               <p:sp>
                 <p:nvSpPr>
                   <p:cNvPr id="25" name="Textfeld 24">
@@ -14420,8 +14439,8 @@
               </p:sp>
             </mc:Fallback>
           </mc:AlternateContent>
-          <mc:AlternateContent xmlns:mc="http://schemas.openxmlformats.org/markup-compatibility/2006">
-            <mc:Choice xmlns:a14="http://schemas.microsoft.com/office/drawing/2010/main" Requires="a14">
+          <mc:AlternateContent xmlns:mc="http://schemas.openxmlformats.org/markup-compatibility/2006" xmlns:a14="http://schemas.microsoft.com/office/drawing/2010/main">
+            <mc:Choice Requires="a14">
               <p:sp>
                 <p:nvSpPr>
                   <p:cNvPr id="26" name="Textfeld 25">
@@ -14493,7 +14512,7 @@
                 </p:txBody>
               </p:sp>
             </mc:Choice>
-            <mc:Fallback>
+            <mc:Fallback xmlns="">
               <p:sp>
                 <p:nvSpPr>
                   <p:cNvPr id="26" name="Textfeld 25">
@@ -14736,8 +14755,8 @@
               </a:fontRef>
             </p:style>
           </p:cxnSp>
-          <mc:AlternateContent xmlns:mc="http://schemas.openxmlformats.org/markup-compatibility/2006">
-            <mc:Choice xmlns:a14="http://schemas.microsoft.com/office/drawing/2010/main" Requires="a14">
+          <mc:AlternateContent xmlns:mc="http://schemas.openxmlformats.org/markup-compatibility/2006" xmlns:a14="http://schemas.microsoft.com/office/drawing/2010/main">
+            <mc:Choice Requires="a14">
               <p:sp>
                 <p:nvSpPr>
                   <p:cNvPr id="100" name="Textfeld 99">
@@ -14809,7 +14828,7 @@
                 </p:txBody>
               </p:sp>
             </mc:Choice>
-            <mc:Fallback>
+            <mc:Fallback xmlns="">
               <p:sp>
                 <p:nvSpPr>
                   <p:cNvPr id="100" name="Textfeld 99">
@@ -14854,8 +14873,8 @@
               </p:sp>
             </mc:Fallback>
           </mc:AlternateContent>
-          <mc:AlternateContent xmlns:mc="http://schemas.openxmlformats.org/markup-compatibility/2006">
-            <mc:Choice xmlns:a14="http://schemas.microsoft.com/office/drawing/2010/main" Requires="a14">
+          <mc:AlternateContent xmlns:mc="http://schemas.openxmlformats.org/markup-compatibility/2006" xmlns:a14="http://schemas.microsoft.com/office/drawing/2010/main">
+            <mc:Choice Requires="a14">
               <p:sp>
                 <p:nvSpPr>
                   <p:cNvPr id="101" name="Textfeld 100">
@@ -14927,7 +14946,7 @@
                 </p:txBody>
               </p:sp>
             </mc:Choice>
-            <mc:Fallback>
+            <mc:Fallback xmlns="">
               <p:sp>
                 <p:nvSpPr>
                   <p:cNvPr id="101" name="Textfeld 100">
@@ -14972,8 +14991,8 @@
               </p:sp>
             </mc:Fallback>
           </mc:AlternateContent>
-          <mc:AlternateContent xmlns:mc="http://schemas.openxmlformats.org/markup-compatibility/2006">
-            <mc:Choice xmlns:a14="http://schemas.microsoft.com/office/drawing/2010/main" Requires="a14">
+          <mc:AlternateContent xmlns:mc="http://schemas.openxmlformats.org/markup-compatibility/2006" xmlns:a14="http://schemas.microsoft.com/office/drawing/2010/main">
+            <mc:Choice Requires="a14">
               <p:sp>
                 <p:nvSpPr>
                   <p:cNvPr id="102" name="Textfeld 101">
@@ -15045,7 +15064,7 @@
                 </p:txBody>
               </p:sp>
             </mc:Choice>
-            <mc:Fallback>
+            <mc:Fallback xmlns="">
               <p:sp>
                 <p:nvSpPr>
                   <p:cNvPr id="102" name="Textfeld 101">
@@ -15287,8 +15306,8 @@
               </a:fontRef>
             </p:style>
           </p:cxnSp>
-          <mc:AlternateContent xmlns:mc="http://schemas.openxmlformats.org/markup-compatibility/2006">
-            <mc:Choice xmlns:a14="http://schemas.microsoft.com/office/drawing/2010/main" Requires="a14">
+          <mc:AlternateContent xmlns:mc="http://schemas.openxmlformats.org/markup-compatibility/2006" xmlns:a14="http://schemas.microsoft.com/office/drawing/2010/main">
+            <mc:Choice Requires="a14">
               <p:sp>
                 <p:nvSpPr>
                   <p:cNvPr id="108" name="Textfeld 107">
@@ -15363,7 +15382,7 @@
                 </p:txBody>
               </p:sp>
             </mc:Choice>
-            <mc:Fallback>
+            <mc:Fallback xmlns="">
               <p:sp>
                 <p:nvSpPr>
                   <p:cNvPr id="108" name="Textfeld 107">
@@ -15408,8 +15427,8 @@
               </p:sp>
             </mc:Fallback>
           </mc:AlternateContent>
-          <mc:AlternateContent xmlns:mc="http://schemas.openxmlformats.org/markup-compatibility/2006">
-            <mc:Choice xmlns:a14="http://schemas.microsoft.com/office/drawing/2010/main" Requires="a14">
+          <mc:AlternateContent xmlns:mc="http://schemas.openxmlformats.org/markup-compatibility/2006" xmlns:a14="http://schemas.microsoft.com/office/drawing/2010/main">
+            <mc:Choice Requires="a14">
               <p:sp>
                 <p:nvSpPr>
                   <p:cNvPr id="109" name="Textfeld 108">
@@ -15484,7 +15503,7 @@
                 </p:txBody>
               </p:sp>
             </mc:Choice>
-            <mc:Fallback>
+            <mc:Fallback xmlns="">
               <p:sp>
                 <p:nvSpPr>
                   <p:cNvPr id="109" name="Textfeld 108">
@@ -15529,8 +15548,8 @@
               </p:sp>
             </mc:Fallback>
           </mc:AlternateContent>
-          <mc:AlternateContent xmlns:mc="http://schemas.openxmlformats.org/markup-compatibility/2006">
-            <mc:Choice xmlns:a14="http://schemas.microsoft.com/office/drawing/2010/main" Requires="a14">
+          <mc:AlternateContent xmlns:mc="http://schemas.openxmlformats.org/markup-compatibility/2006" xmlns:a14="http://schemas.microsoft.com/office/drawing/2010/main">
+            <mc:Choice Requires="a14">
               <p:sp>
                 <p:nvSpPr>
                   <p:cNvPr id="110" name="Textfeld 109">
@@ -15605,7 +15624,7 @@
                 </p:txBody>
               </p:sp>
             </mc:Choice>
-            <mc:Fallback>
+            <mc:Fallback xmlns="">
               <p:sp>
                 <p:nvSpPr>
                   <p:cNvPr id="110" name="Textfeld 109">
@@ -15952,8 +15971,8 @@
             </a:fontRef>
           </p:style>
         </p:cxnSp>
-        <mc:AlternateContent xmlns:mc="http://schemas.openxmlformats.org/markup-compatibility/2006">
-          <mc:Choice xmlns:a14="http://schemas.microsoft.com/office/drawing/2010/main" Requires="a14">
+        <mc:AlternateContent xmlns:mc="http://schemas.openxmlformats.org/markup-compatibility/2006" xmlns:a14="http://schemas.microsoft.com/office/drawing/2010/main">
+          <mc:Choice Requires="a14">
             <p:sp>
               <p:nvSpPr>
                 <p:cNvPr id="140" name="Textfeld 139">
@@ -16025,7 +16044,7 @@
               </p:txBody>
             </p:sp>
           </mc:Choice>
-          <mc:Fallback>
+          <mc:Fallback xmlns="">
             <p:sp>
               <p:nvSpPr>
                 <p:cNvPr id="140" name="Textfeld 139">
@@ -16070,8 +16089,8 @@
             </p:sp>
           </mc:Fallback>
         </mc:AlternateContent>
-        <mc:AlternateContent xmlns:mc="http://schemas.openxmlformats.org/markup-compatibility/2006">
-          <mc:Choice xmlns:a14="http://schemas.microsoft.com/office/drawing/2010/main" Requires="a14">
+        <mc:AlternateContent xmlns:mc="http://schemas.openxmlformats.org/markup-compatibility/2006" xmlns:a14="http://schemas.microsoft.com/office/drawing/2010/main">
+          <mc:Choice Requires="a14">
             <p:sp>
               <p:nvSpPr>
                 <p:cNvPr id="141" name="Textfeld 140">
@@ -16143,7 +16162,7 @@
               </p:txBody>
             </p:sp>
           </mc:Choice>
-          <mc:Fallback>
+          <mc:Fallback xmlns="">
             <p:sp>
               <p:nvSpPr>
                 <p:cNvPr id="141" name="Textfeld 140">
@@ -16188,8 +16207,8 @@
             </p:sp>
           </mc:Fallback>
         </mc:AlternateContent>
-        <mc:AlternateContent xmlns:mc="http://schemas.openxmlformats.org/markup-compatibility/2006">
-          <mc:Choice xmlns:a14="http://schemas.microsoft.com/office/drawing/2010/main" Requires="a14">
+        <mc:AlternateContent xmlns:mc="http://schemas.openxmlformats.org/markup-compatibility/2006" xmlns:a14="http://schemas.microsoft.com/office/drawing/2010/main">
+          <mc:Choice Requires="a14">
             <p:sp>
               <p:nvSpPr>
                 <p:cNvPr id="142" name="Textfeld 141">
@@ -16261,7 +16280,7 @@
               </p:txBody>
             </p:sp>
           </mc:Choice>
-          <mc:Fallback>
+          <mc:Fallback xmlns="">
             <p:sp>
               <p:nvSpPr>
                 <p:cNvPr id="142" name="Textfeld 141">

</xml_diff>

<commit_message>
Added second Modelling tutorial, started on solutions, no json yet
</commit_message>
<xml_diff>
--- a/robotics/Resources/Images/Modelling/Robot images.pptx
+++ b/robotics/Resources/Images/Modelling/Robot images.pptx
@@ -11,6 +11,9 @@
     <p:sldId id="258" r:id="rId5"/>
     <p:sldId id="260" r:id="rId6"/>
     <p:sldId id="261" r:id="rId7"/>
+    <p:sldId id="262" r:id="rId8"/>
+    <p:sldId id="263" r:id="rId9"/>
+    <p:sldId id="264" r:id="rId10"/>
   </p:sldIdLst>
   <p:sldSz cx="6858000" cy="12192000"/>
   <p:notesSz cx="6858000" cy="9144000"/>
@@ -26750,6 +26753,669 @@
 </p:sld>
 </file>
 
+<file path=ppt/slides/slide7.xml><?xml version="1.0" encoding="utf-8"?>
+<p:sld xmlns:a="http://schemas.openxmlformats.org/drawingml/2006/main" xmlns:r="http://schemas.openxmlformats.org/officeDocument/2006/relationships" xmlns:p="http://schemas.openxmlformats.org/presentationml/2006/main">
+  <p:cSld>
+    <p:spTree>
+      <p:nvGrpSpPr>
+        <p:cNvPr id="1" name=""/>
+        <p:cNvGrpSpPr/>
+        <p:nvPr/>
+      </p:nvGrpSpPr>
+      <p:grpSpPr>
+        <a:xfrm>
+          <a:off x="0" y="0"/>
+          <a:ext cx="0" cy="0"/>
+          <a:chOff x="0" y="0"/>
+          <a:chExt cx="0" cy="0"/>
+        </a:xfrm>
+      </p:grpSpPr>
+      <p:grpSp>
+        <p:nvGrpSpPr>
+          <p:cNvPr id="14" name="Gruppieren 13">
+            <a:extLst>
+              <a:ext uri="{FF2B5EF4-FFF2-40B4-BE49-F238E27FC236}">
+                <a16:creationId xmlns:a16="http://schemas.microsoft.com/office/drawing/2014/main" id="{7C31E7F5-EDC4-DA11-7D5C-5C4876987E26}"/>
+              </a:ext>
+            </a:extLst>
+          </p:cNvPr>
+          <p:cNvGrpSpPr/>
+          <p:nvPr/>
+        </p:nvGrpSpPr>
+        <p:grpSpPr>
+          <a:xfrm>
+            <a:off x="0" y="1730812"/>
+            <a:ext cx="6858000" cy="9143999"/>
+            <a:chOff x="0" y="1730812"/>
+            <a:chExt cx="6858000" cy="9143999"/>
+          </a:xfrm>
+        </p:grpSpPr>
+        <p:pic>
+          <p:nvPicPr>
+            <p:cNvPr id="6" name="Grafik 5" descr="Ein Bild, das Hahn, Silber, Licht enthält.&#10;&#10;KI-generierte Inhalte können fehlerhaft sein.">
+              <a:extLst>
+                <a:ext uri="{FF2B5EF4-FFF2-40B4-BE49-F238E27FC236}">
+                  <a16:creationId xmlns:a16="http://schemas.microsoft.com/office/drawing/2014/main" id="{62AFEA39-690A-5A78-1597-A2C3C5B2B07D}"/>
+                </a:ext>
+              </a:extLst>
+            </p:cNvPr>
+            <p:cNvPicPr>
+              <a:picLocks noChangeAspect="1"/>
+            </p:cNvPicPr>
+            <p:nvPr/>
+          </p:nvPicPr>
+          <p:blipFill>
+            <a:blip r:embed="rId2">
+              <a:extLst>
+                <a:ext uri="{28A0092B-C50C-407E-A947-70E740481C1C}">
+                  <a14:useLocalDpi xmlns:a14="http://schemas.microsoft.com/office/drawing/2010/main" val="0"/>
+                </a:ext>
+              </a:extLst>
+            </a:blip>
+            <a:stretch>
+              <a:fillRect/>
+            </a:stretch>
+          </p:blipFill>
+          <p:spPr>
+            <a:xfrm>
+              <a:off x="0" y="1730812"/>
+              <a:ext cx="6858000" cy="9143999"/>
+            </a:xfrm>
+            <a:prstGeom prst="rect">
+              <a:avLst/>
+            </a:prstGeom>
+          </p:spPr>
+        </p:pic>
+        <p:grpSp>
+          <p:nvGrpSpPr>
+            <p:cNvPr id="7" name="Gruppieren 6">
+              <a:extLst>
+                <a:ext uri="{FF2B5EF4-FFF2-40B4-BE49-F238E27FC236}">
+                  <a16:creationId xmlns:a16="http://schemas.microsoft.com/office/drawing/2014/main" id="{C8284938-F010-3BCC-95F7-AA4AF3B84FC7}"/>
+                </a:ext>
+              </a:extLst>
+            </p:cNvPr>
+            <p:cNvGrpSpPr/>
+            <p:nvPr/>
+          </p:nvGrpSpPr>
+          <p:grpSpPr>
+            <a:xfrm>
+              <a:off x="3134441" y="7924800"/>
+              <a:ext cx="3165856" cy="2781560"/>
+              <a:chOff x="1832404" y="449443"/>
+              <a:chExt cx="2139870" cy="1880117"/>
+            </a:xfrm>
+          </p:grpSpPr>
+          <p:cxnSp>
+            <p:nvCxnSpPr>
+              <p:cNvPr id="8" name="Gerade Verbindung mit Pfeil 7">
+                <a:extLst>
+                  <a:ext uri="{FF2B5EF4-FFF2-40B4-BE49-F238E27FC236}">
+                    <a16:creationId xmlns:a16="http://schemas.microsoft.com/office/drawing/2014/main" id="{D5CF40A4-2789-A6F7-6089-219A33E88B1C}"/>
+                  </a:ext>
+                </a:extLst>
+              </p:cNvPr>
+              <p:cNvCxnSpPr>
+                <a:cxnSpLocks/>
+              </p:cNvCxnSpPr>
+              <p:nvPr/>
+            </p:nvCxnSpPr>
+            <p:spPr>
+              <a:xfrm flipV="1">
+                <a:off x="2682727" y="757963"/>
+                <a:ext cx="1" cy="936000"/>
+              </a:xfrm>
+              <a:prstGeom prst="straightConnector1">
+                <a:avLst/>
+              </a:prstGeom>
+              <a:ln w="76200">
+                <a:solidFill>
+                  <a:srgbClr val="0070C0"/>
+                </a:solidFill>
+                <a:tailEnd type="triangle"/>
+              </a:ln>
+            </p:spPr>
+            <p:style>
+              <a:lnRef idx="2">
+                <a:schemeClr val="accent1"/>
+              </a:lnRef>
+              <a:fillRef idx="0">
+                <a:schemeClr val="accent1"/>
+              </a:fillRef>
+              <a:effectRef idx="1">
+                <a:schemeClr val="accent1"/>
+              </a:effectRef>
+              <a:fontRef idx="minor">
+                <a:schemeClr val="tx1"/>
+              </a:fontRef>
+            </p:style>
+          </p:cxnSp>
+          <p:cxnSp>
+            <p:nvCxnSpPr>
+              <p:cNvPr id="9" name="Gerade Verbindung mit Pfeil 8">
+                <a:extLst>
+                  <a:ext uri="{FF2B5EF4-FFF2-40B4-BE49-F238E27FC236}">
+                    <a16:creationId xmlns:a16="http://schemas.microsoft.com/office/drawing/2014/main" id="{DB2446F6-A0BB-1937-59DC-397B4104962F}"/>
+                  </a:ext>
+                </a:extLst>
+              </p:cNvPr>
+              <p:cNvCxnSpPr>
+                <a:cxnSpLocks/>
+              </p:cNvCxnSpPr>
+              <p:nvPr/>
+            </p:nvCxnSpPr>
+            <p:spPr>
+              <a:xfrm flipV="1">
+                <a:off x="2671444" y="1658908"/>
+                <a:ext cx="936000" cy="0"/>
+              </a:xfrm>
+              <a:prstGeom prst="straightConnector1">
+                <a:avLst/>
+              </a:prstGeom>
+              <a:ln w="76200">
+                <a:solidFill>
+                  <a:schemeClr val="accent6"/>
+                </a:solidFill>
+                <a:tailEnd type="triangle"/>
+              </a:ln>
+            </p:spPr>
+            <p:style>
+              <a:lnRef idx="2">
+                <a:schemeClr val="accent1"/>
+              </a:lnRef>
+              <a:fillRef idx="0">
+                <a:schemeClr val="accent1"/>
+              </a:fillRef>
+              <a:effectRef idx="1">
+                <a:schemeClr val="accent1"/>
+              </a:effectRef>
+              <a:fontRef idx="minor">
+                <a:schemeClr val="tx1"/>
+              </a:fontRef>
+            </p:style>
+          </p:cxnSp>
+          <mc:AlternateContent xmlns:mc="http://schemas.openxmlformats.org/markup-compatibility/2006">
+            <mc:Choice xmlns:a14="http://schemas.microsoft.com/office/drawing/2010/main" Requires="a14">
+              <p:sp>
+                <p:nvSpPr>
+                  <p:cNvPr id="10" name="Textfeld 9">
+                    <a:extLst>
+                      <a:ext uri="{FF2B5EF4-FFF2-40B4-BE49-F238E27FC236}">
+                        <a16:creationId xmlns:a16="http://schemas.microsoft.com/office/drawing/2014/main" id="{C6E759E0-3698-0F16-B4B4-E9A47D01AB5D}"/>
+                      </a:ext>
+                    </a:extLst>
+                  </p:cNvPr>
+                  <p:cNvSpPr txBox="1"/>
+                  <p:nvPr/>
+                </p:nvSpPr>
+                <p:spPr>
+                  <a:xfrm flipH="1">
+                    <a:off x="3514335" y="1468343"/>
+                    <a:ext cx="457939" cy="395262"/>
+                  </a:xfrm>
+                  <a:prstGeom prst="rect">
+                    <a:avLst/>
+                  </a:prstGeom>
+                  <a:noFill/>
+                </p:spPr>
+                <p:txBody>
+                  <a:bodyPr wrap="square" rtlCol="0">
+                    <a:spAutoFit/>
+                  </a:bodyPr>
+                  <a:lstStyle/>
+                  <a:p>
+                    <a:pPr/>
+                    <a14:m>
+                      <m:oMathPara xmlns:m="http://schemas.openxmlformats.org/officeDocument/2006/math">
+                        <m:oMathParaPr>
+                          <m:jc m:val="centerGroup"/>
+                        </m:oMathParaPr>
+                        <m:oMath xmlns:m="http://schemas.openxmlformats.org/officeDocument/2006/math">
+                          <m:sSub>
+                            <m:sSubPr>
+                              <m:ctrlPr>
+                                <a:rPr lang="de-DE" sz="3200" dirty="0" smtClean="0">
+                                  <a:latin typeface="Cambria Math" panose="02040503050406030204" pitchFamily="18" charset="0"/>
+                                </a:rPr>
+                              </m:ctrlPr>
+                            </m:sSubPr>
+                            <m:e>
+                              <m:r>
+                                <m:rPr>
+                                  <m:sty m:val="p"/>
+                                </m:rPr>
+                                <a:rPr lang="de-DE" sz="3200" b="0" i="0" dirty="0" smtClean="0">
+                                  <a:latin typeface="Cambria Math" panose="02040503050406030204" pitchFamily="18" charset="0"/>
+                                </a:rPr>
+                                <m:t>Y</m:t>
+                              </m:r>
+                            </m:e>
+                            <m:sub>
+                              <m:r>
+                                <m:rPr>
+                                  <m:sty m:val="p"/>
+                                </m:rPr>
+                                <a:rPr lang="de-DE" sz="3200" b="0" i="0" dirty="0" smtClean="0">
+                                  <a:latin typeface="Cambria Math" panose="02040503050406030204" pitchFamily="18" charset="0"/>
+                                </a:rPr>
+                                <m:t>base</m:t>
+                              </m:r>
+                            </m:sub>
+                          </m:sSub>
+                        </m:oMath>
+                      </m:oMathPara>
+                    </a14:m>
+                    <a:endParaRPr lang="de-DE" sz="3200" dirty="0"/>
+                  </a:p>
+                </p:txBody>
+              </p:sp>
+            </mc:Choice>
+            <mc:Fallback>
+              <p:sp>
+                <p:nvSpPr>
+                  <p:cNvPr id="10" name="Textfeld 9">
+                    <a:extLst>
+                      <a:ext uri="{FF2B5EF4-FFF2-40B4-BE49-F238E27FC236}">
+                        <a16:creationId xmlns:a16="http://schemas.microsoft.com/office/drawing/2014/main" id="{C6E759E0-3698-0F16-B4B4-E9A47D01AB5D}"/>
+                      </a:ext>
+                    </a:extLst>
+                  </p:cNvPr>
+                  <p:cNvSpPr txBox="1">
+                    <a:spLocks noRot="1" noChangeAspect="1" noMove="1" noResize="1" noEditPoints="1" noAdjustHandles="1" noChangeArrowheads="1" noChangeShapeType="1" noTextEdit="1"/>
+                  </p:cNvSpPr>
+                  <p:nvPr/>
+                </p:nvSpPr>
+                <p:spPr>
+                  <a:xfrm flipH="1">
+                    <a:off x="3514335" y="1468343"/>
+                    <a:ext cx="457939" cy="395262"/>
+                  </a:xfrm>
+                  <a:prstGeom prst="rect">
+                    <a:avLst/>
+                  </a:prstGeom>
+                  <a:blipFill>
+                    <a:blip r:embed="rId3"/>
+                    <a:stretch>
+                      <a:fillRect r="-37500"/>
+                    </a:stretch>
+                  </a:blipFill>
+                </p:spPr>
+                <p:txBody>
+                  <a:bodyPr/>
+                  <a:lstStyle/>
+                  <a:p>
+                    <a:r>
+                      <a:rPr lang="en-US">
+                        <a:noFill/>
+                      </a:rPr>
+                      <a:t> </a:t>
+                    </a:r>
+                  </a:p>
+                </p:txBody>
+              </p:sp>
+            </mc:Fallback>
+          </mc:AlternateContent>
+          <mc:AlternateContent xmlns:mc="http://schemas.openxmlformats.org/markup-compatibility/2006">
+            <mc:Choice xmlns:a14="http://schemas.microsoft.com/office/drawing/2010/main" Requires="a14">
+              <p:sp>
+                <p:nvSpPr>
+                  <p:cNvPr id="11" name="Textfeld 10">
+                    <a:extLst>
+                      <a:ext uri="{FF2B5EF4-FFF2-40B4-BE49-F238E27FC236}">
+                        <a16:creationId xmlns:a16="http://schemas.microsoft.com/office/drawing/2014/main" id="{43A36DBC-A483-78EC-9EA0-D2486C04CBE5}"/>
+                      </a:ext>
+                    </a:extLst>
+                  </p:cNvPr>
+                  <p:cNvSpPr txBox="1"/>
+                  <p:nvPr/>
+                </p:nvSpPr>
+                <p:spPr>
+                  <a:xfrm flipH="1">
+                    <a:off x="1832404" y="1934298"/>
+                    <a:ext cx="576916" cy="395262"/>
+                  </a:xfrm>
+                  <a:prstGeom prst="rect">
+                    <a:avLst/>
+                  </a:prstGeom>
+                  <a:noFill/>
+                </p:spPr>
+                <p:txBody>
+                  <a:bodyPr wrap="square" rtlCol="0">
+                    <a:spAutoFit/>
+                  </a:bodyPr>
+                  <a:lstStyle/>
+                  <a:p>
+                    <a:pPr/>
+                    <a14:m>
+                      <m:oMathPara xmlns:m="http://schemas.openxmlformats.org/officeDocument/2006/math">
+                        <m:oMathParaPr>
+                          <m:jc m:val="centerGroup"/>
+                        </m:oMathParaPr>
+                        <m:oMath xmlns:m="http://schemas.openxmlformats.org/officeDocument/2006/math">
+                          <m:sSub>
+                            <m:sSubPr>
+                              <m:ctrlPr>
+                                <a:rPr lang="de-DE" sz="3200" i="1" dirty="0" smtClean="0">
+                                  <a:latin typeface="Cambria Math" panose="02040503050406030204" pitchFamily="18" charset="0"/>
+                                </a:rPr>
+                              </m:ctrlPr>
+                            </m:sSubPr>
+                            <m:e>
+                              <m:r>
+                                <m:rPr>
+                                  <m:sty m:val="p"/>
+                                </m:rPr>
+                                <a:rPr lang="de-DE" sz="3200" b="0" i="0" dirty="0" smtClean="0">
+                                  <a:latin typeface="Cambria Math" panose="02040503050406030204" pitchFamily="18" charset="0"/>
+                                </a:rPr>
+                                <m:t>X</m:t>
+                              </m:r>
+                            </m:e>
+                            <m:sub>
+                              <m:r>
+                                <m:rPr>
+                                  <m:sty m:val="p"/>
+                                </m:rPr>
+                                <a:rPr lang="de-DE" sz="3200" b="0" i="0" dirty="0" smtClean="0">
+                                  <a:latin typeface="Cambria Math" panose="02040503050406030204" pitchFamily="18" charset="0"/>
+                                </a:rPr>
+                                <m:t>Base</m:t>
+                              </m:r>
+                            </m:sub>
+                          </m:sSub>
+                        </m:oMath>
+                      </m:oMathPara>
+                    </a14:m>
+                    <a:endParaRPr lang="de-DE" sz="3200" dirty="0"/>
+                  </a:p>
+                </p:txBody>
+              </p:sp>
+            </mc:Choice>
+            <mc:Fallback>
+              <p:sp>
+                <p:nvSpPr>
+                  <p:cNvPr id="11" name="Textfeld 10">
+                    <a:extLst>
+                      <a:ext uri="{FF2B5EF4-FFF2-40B4-BE49-F238E27FC236}">
+                        <a16:creationId xmlns:a16="http://schemas.microsoft.com/office/drawing/2014/main" id="{43A36DBC-A483-78EC-9EA0-D2486C04CBE5}"/>
+                      </a:ext>
+                    </a:extLst>
+                  </p:cNvPr>
+                  <p:cNvSpPr txBox="1">
+                    <a:spLocks noRot="1" noChangeAspect="1" noMove="1" noResize="1" noEditPoints="1" noAdjustHandles="1" noChangeArrowheads="1" noChangeShapeType="1" noTextEdit="1"/>
+                  </p:cNvSpPr>
+                  <p:nvPr/>
+                </p:nvSpPr>
+                <p:spPr>
+                  <a:xfrm flipH="1">
+                    <a:off x="1832404" y="1934298"/>
+                    <a:ext cx="576916" cy="395262"/>
+                  </a:xfrm>
+                  <a:prstGeom prst="rect">
+                    <a:avLst/>
+                  </a:prstGeom>
+                  <a:blipFill>
+                    <a:blip r:embed="rId4"/>
+                    <a:stretch>
+                      <a:fillRect r="-17143"/>
+                    </a:stretch>
+                  </a:blipFill>
+                </p:spPr>
+                <p:txBody>
+                  <a:bodyPr/>
+                  <a:lstStyle/>
+                  <a:p>
+                    <a:r>
+                      <a:rPr lang="en-US">
+                        <a:noFill/>
+                      </a:rPr>
+                      <a:t> </a:t>
+                    </a:r>
+                  </a:p>
+                </p:txBody>
+              </p:sp>
+            </mc:Fallback>
+          </mc:AlternateContent>
+          <mc:AlternateContent xmlns:mc="http://schemas.openxmlformats.org/markup-compatibility/2006">
+            <mc:Choice xmlns:a14="http://schemas.microsoft.com/office/drawing/2010/main" Requires="a14">
+              <p:sp>
+                <p:nvSpPr>
+                  <p:cNvPr id="12" name="Textfeld 11">
+                    <a:extLst>
+                      <a:ext uri="{FF2B5EF4-FFF2-40B4-BE49-F238E27FC236}">
+                        <a16:creationId xmlns:a16="http://schemas.microsoft.com/office/drawing/2014/main" id="{C68FFD51-FDD2-B3CB-0662-A374202CFAC7}"/>
+                      </a:ext>
+                    </a:extLst>
+                  </p:cNvPr>
+                  <p:cNvSpPr txBox="1"/>
+                  <p:nvPr/>
+                </p:nvSpPr>
+                <p:spPr>
+                  <a:xfrm flipH="1">
+                    <a:off x="2492497" y="449443"/>
+                    <a:ext cx="373613" cy="395262"/>
+                  </a:xfrm>
+                  <a:prstGeom prst="rect">
+                    <a:avLst/>
+                  </a:prstGeom>
+                  <a:noFill/>
+                </p:spPr>
+                <p:txBody>
+                  <a:bodyPr wrap="square" rtlCol="0">
+                    <a:spAutoFit/>
+                  </a:bodyPr>
+                  <a:lstStyle/>
+                  <a:p>
+                    <a:pPr/>
+                    <a14:m>
+                      <m:oMathPara xmlns:m="http://schemas.openxmlformats.org/officeDocument/2006/math">
+                        <m:oMathParaPr>
+                          <m:jc m:val="centerGroup"/>
+                        </m:oMathParaPr>
+                        <m:oMath xmlns:m="http://schemas.openxmlformats.org/officeDocument/2006/math">
+                          <m:sSub>
+                            <m:sSubPr>
+                              <m:ctrlPr>
+                                <a:rPr lang="de-DE" sz="3200" i="1" smtClean="0">
+                                  <a:latin typeface="Cambria Math" panose="02040503050406030204" pitchFamily="18" charset="0"/>
+                                </a:rPr>
+                              </m:ctrlPr>
+                            </m:sSubPr>
+                            <m:e>
+                              <m:r>
+                                <m:rPr>
+                                  <m:sty m:val="p"/>
+                                </m:rPr>
+                                <a:rPr lang="de-DE" sz="3200" b="0" i="0" smtClean="0">
+                                  <a:latin typeface="Cambria Math" panose="02040503050406030204" pitchFamily="18" charset="0"/>
+                                </a:rPr>
+                                <m:t>Z</m:t>
+                              </m:r>
+                            </m:e>
+                            <m:sub>
+                              <m:r>
+                                <m:rPr>
+                                  <m:sty m:val="p"/>
+                                </m:rPr>
+                                <a:rPr lang="de-DE" sz="3200" b="0" i="0" smtClean="0">
+                                  <a:latin typeface="Cambria Math" panose="02040503050406030204" pitchFamily="18" charset="0"/>
+                                </a:rPr>
+                                <m:t>Base</m:t>
+                              </m:r>
+                            </m:sub>
+                          </m:sSub>
+                        </m:oMath>
+                      </m:oMathPara>
+                    </a14:m>
+                    <a:endParaRPr lang="de-DE" sz="3200" dirty="0"/>
+                  </a:p>
+                </p:txBody>
+              </p:sp>
+            </mc:Choice>
+            <mc:Fallback>
+              <p:sp>
+                <p:nvSpPr>
+                  <p:cNvPr id="12" name="Textfeld 11">
+                    <a:extLst>
+                      <a:ext uri="{FF2B5EF4-FFF2-40B4-BE49-F238E27FC236}">
+                        <a16:creationId xmlns:a16="http://schemas.microsoft.com/office/drawing/2014/main" id="{C68FFD51-FDD2-B3CB-0662-A374202CFAC7}"/>
+                      </a:ext>
+                    </a:extLst>
+                  </p:cNvPr>
+                  <p:cNvSpPr txBox="1">
+                    <a:spLocks noRot="1" noChangeAspect="1" noMove="1" noResize="1" noEditPoints="1" noAdjustHandles="1" noChangeArrowheads="1" noChangeShapeType="1" noTextEdit="1"/>
+                  </p:cNvSpPr>
+                  <p:nvPr/>
+                </p:nvSpPr>
+                <p:spPr>
+                  <a:xfrm flipH="1">
+                    <a:off x="2492497" y="449443"/>
+                    <a:ext cx="373613" cy="395262"/>
+                  </a:xfrm>
+                  <a:prstGeom prst="rect">
+                    <a:avLst/>
+                  </a:prstGeom>
+                  <a:blipFill>
+                    <a:blip r:embed="rId5"/>
+                    <a:stretch>
+                      <a:fillRect r="-75824"/>
+                    </a:stretch>
+                  </a:blipFill>
+                </p:spPr>
+                <p:txBody>
+                  <a:bodyPr/>
+                  <a:lstStyle/>
+                  <a:p>
+                    <a:r>
+                      <a:rPr lang="en-US">
+                        <a:noFill/>
+                      </a:rPr>
+                      <a:t> </a:t>
+                    </a:r>
+                  </a:p>
+                </p:txBody>
+              </p:sp>
+            </mc:Fallback>
+          </mc:AlternateContent>
+          <p:cxnSp>
+            <p:nvCxnSpPr>
+              <p:cNvPr id="13" name="Gerade Verbindung mit Pfeil 12">
+                <a:extLst>
+                  <a:ext uri="{FF2B5EF4-FFF2-40B4-BE49-F238E27FC236}">
+                    <a16:creationId xmlns:a16="http://schemas.microsoft.com/office/drawing/2014/main" id="{2EBB7A33-FB93-DF05-CA1E-74F7E2D01756}"/>
+                  </a:ext>
+                </a:extLst>
+              </p:cNvPr>
+              <p:cNvCxnSpPr>
+                <a:cxnSpLocks/>
+              </p:cNvCxnSpPr>
+              <p:nvPr/>
+            </p:nvCxnSpPr>
+            <p:spPr>
+              <a:xfrm flipH="1">
+                <a:off x="2214727" y="1667831"/>
+                <a:ext cx="468000" cy="468000"/>
+              </a:xfrm>
+              <a:prstGeom prst="straightConnector1">
+                <a:avLst/>
+              </a:prstGeom>
+              <a:ln w="76200">
+                <a:solidFill>
+                  <a:srgbClr val="FF0000"/>
+                </a:solidFill>
+                <a:tailEnd type="triangle"/>
+              </a:ln>
+            </p:spPr>
+            <p:style>
+              <a:lnRef idx="2">
+                <a:schemeClr val="accent1"/>
+              </a:lnRef>
+              <a:fillRef idx="0">
+                <a:schemeClr val="accent1"/>
+              </a:fillRef>
+              <a:effectRef idx="1">
+                <a:schemeClr val="accent1"/>
+              </a:effectRef>
+              <a:fontRef idx="minor">
+                <a:schemeClr val="tx1"/>
+              </a:fontRef>
+            </p:style>
+          </p:cxnSp>
+        </p:grpSp>
+      </p:grpSp>
+    </p:spTree>
+    <p:extLst>
+      <p:ext uri="{BB962C8B-B14F-4D97-AF65-F5344CB8AC3E}">
+        <p14:creationId xmlns:p14="http://schemas.microsoft.com/office/powerpoint/2010/main" val="199770545"/>
+      </p:ext>
+    </p:extLst>
+  </p:cSld>
+  <p:clrMapOvr>
+    <a:masterClrMapping/>
+  </p:clrMapOvr>
+</p:sld>
+</file>
+
+<file path=ppt/slides/slide8.xml><?xml version="1.0" encoding="utf-8"?>
+<p:sld xmlns:a="http://schemas.openxmlformats.org/drawingml/2006/main" xmlns:r="http://schemas.openxmlformats.org/officeDocument/2006/relationships" xmlns:p="http://schemas.openxmlformats.org/presentationml/2006/main">
+  <p:cSld>
+    <p:spTree>
+      <p:nvGrpSpPr>
+        <p:cNvPr id="1" name=""/>
+        <p:cNvGrpSpPr/>
+        <p:nvPr/>
+      </p:nvGrpSpPr>
+      <p:grpSpPr>
+        <a:xfrm>
+          <a:off x="0" y="0"/>
+          <a:ext cx="0" cy="0"/>
+          <a:chOff x="0" y="0"/>
+          <a:chExt cx="0" cy="0"/>
+        </a:xfrm>
+      </p:grpSpPr>
+    </p:spTree>
+    <p:extLst>
+      <p:ext uri="{BB962C8B-B14F-4D97-AF65-F5344CB8AC3E}">
+        <p14:creationId xmlns:p14="http://schemas.microsoft.com/office/powerpoint/2010/main" val="4122538211"/>
+      </p:ext>
+    </p:extLst>
+  </p:cSld>
+  <p:clrMapOvr>
+    <a:masterClrMapping/>
+  </p:clrMapOvr>
+</p:sld>
+</file>
+
+<file path=ppt/slides/slide9.xml><?xml version="1.0" encoding="utf-8"?>
+<p:sld xmlns:a="http://schemas.openxmlformats.org/drawingml/2006/main" xmlns:r="http://schemas.openxmlformats.org/officeDocument/2006/relationships" xmlns:p="http://schemas.openxmlformats.org/presentationml/2006/main">
+  <p:cSld>
+    <p:spTree>
+      <p:nvGrpSpPr>
+        <p:cNvPr id="1" name=""/>
+        <p:cNvGrpSpPr/>
+        <p:nvPr/>
+      </p:nvGrpSpPr>
+      <p:grpSpPr>
+        <a:xfrm>
+          <a:off x="0" y="0"/>
+          <a:ext cx="0" cy="0"/>
+          <a:chOff x="0" y="0"/>
+          <a:chExt cx="0" cy="0"/>
+        </a:xfrm>
+      </p:grpSpPr>
+    </p:spTree>
+    <p:extLst>
+      <p:ext uri="{BB962C8B-B14F-4D97-AF65-F5344CB8AC3E}">
+        <p14:creationId xmlns:p14="http://schemas.microsoft.com/office/powerpoint/2010/main" val="1295423710"/>
+      </p:ext>
+    </p:extLst>
+  </p:cSld>
+  <p:clrMapOvr>
+    <a:masterClrMapping/>
+  </p:clrMapOvr>
+</p:sld>
+</file>
+
 <file path=ppt/theme/theme1.xml><?xml version="1.0" encoding="utf-8"?>
 <a:theme xmlns:a="http://schemas.openxmlformats.org/drawingml/2006/main" name="Office">
   <a:themeElements>

</xml_diff>